<commit_message>
docs(competition): finalize review submission package
</commit_message>
<xml_diff>
--- a/competition/final-delivery/FINAL-SUBMISSION/04_答辩PPT/校园智序-小序-答辩.pptx
+++ b/competition/final-delivery/FINAL-SUBMISSION/04_答辩PPT/校园智序-小序-答辩.pptx
@@ -148,7 +148,7 @@
     </p:spTree>
     <p:extLst>
       <p:ext uri="{BB962C8B-B14F-4D97-AF65-F5344CB8AC3E}">
-        <p14:creationId xmlns:p14="http://schemas.microsoft.com/office/powerpoint/2010/main" val="4004369571"/>
+        <p14:creationId xmlns:p14="http://schemas.microsoft.com/office/powerpoint/2010/main" val="2304251534"/>
       </p:ext>
     </p:extLst>
   </p:cSld>
@@ -1653,7 +1653,7 @@
       </p:sp>
       <p:pic>
         <p:nvPicPr>
-          <p:cNvPr id="4" name="S00_0003_logo" descr="platform-logo.png"/>
+          <p:cNvPr id="4" name="S00_0003_logo" descr="competition-project\competition\demo-portal\public\branding\platform-logo.png"/>
           <p:cNvPicPr>
             <a:picLocks noChangeAspect="1"/>
           </p:cNvPicPr>
@@ -1811,7 +1811,7 @@
                 <a:ea typeface="Noto Serif SC" pitchFamily="34" charset="-122"/>
                 <a:cs typeface="Noto Serif SC" pitchFamily="34" charset="-120"/>
               </a:rPr>
-              <a:t>校园教学时空智能协同系统</a:t>
+              <a:t>校园教学时空资源智能体</a:t>
             </a:r>
             <a:endParaRPr lang="en-US" sz="2500" dirty="0"/>
           </a:p>
@@ -2322,7 +2322,7 @@
       </p:grpSpPr>
       <p:sp>
         <p:nvSpPr>
-          <p:cNvPr id="2" name="S00_0249_background-field"/>
+          <p:cNvPr id="2" name="S00_0247_background-field"/>
           <p:cNvSpPr/>
           <p:nvPr/>
         </p:nvSpPr>
@@ -2351,7 +2351,7 @@
       </p:sp>
       <p:sp>
         <p:nvSpPr>
-          <p:cNvPr id="3" name="S00_0250_background-arc"/>
+          <p:cNvPr id="3" name="S00_0248_background-arc"/>
           <p:cNvSpPr/>
           <p:nvPr/>
         </p:nvSpPr>
@@ -2380,7 +2380,7 @@
       </p:sp>
       <p:sp>
         <p:nvSpPr>
-          <p:cNvPr id="4" name="S00_0251_text"/>
+          <p:cNvPr id="4" name="S00_0249_text"/>
           <p:cNvSpPr/>
           <p:nvPr/>
         </p:nvSpPr>
@@ -2413,7 +2413,7 @@
                 <a:ea typeface="MiSans" pitchFamily="34" charset="-122"/>
                 <a:cs typeface="MiSans" pitchFamily="34" charset="-120"/>
               </a:rPr>
-              <a:t>为什么相信它</a:t>
+              <a:t>真正的技术创新</a:t>
             </a:r>
             <a:endParaRPr lang="en-US" sz="1000" dirty="0"/>
           </a:p>
@@ -2421,7 +2421,7 @@
       </p:sp>
       <p:sp>
         <p:nvSpPr>
-          <p:cNvPr id="5" name="S00_0252_text"/>
+          <p:cNvPr id="5" name="S00_0250_text"/>
           <p:cNvSpPr/>
           <p:nvPr/>
         </p:nvSpPr>
@@ -2454,7 +2454,7 @@
                 <a:ea typeface="Noto Serif SC" pitchFamily="34" charset="-122"/>
                 <a:cs typeface="Noto Serif SC" pitchFamily="34" charset="-120"/>
               </a:rPr>
-              <a:t>三层各做自己最擅长的事</a:t>
+              <a:t>不是多一个模型，而是让任务接得住</a:t>
             </a:r>
             <a:endParaRPr lang="en-US" sz="2700" dirty="0"/>
           </a:p>
@@ -2462,7 +2462,7 @@
       </p:sp>
       <p:sp>
         <p:nvSpPr>
-          <p:cNvPr id="6" name="S00_0253_text"/>
+          <p:cNvPr id="6" name="S00_0251_text"/>
           <p:cNvSpPr/>
           <p:nvPr/>
         </p:nvSpPr>
@@ -2495,7 +2495,7 @@
                 <a:ea typeface="MiSans" pitchFamily="34" charset="-122"/>
                 <a:cs typeface="MiSans" pitchFamily="34" charset="-120"/>
               </a:rPr>
-              <a:t>不是把技术名词堆在一起，而是把“理解、计算、表达”三件事真正分开。</a:t>
+              <a:t>把多人协作、确定性事实与跨轮次上下文，组织成同一条可复核的任务链。</a:t>
             </a:r>
             <a:endParaRPr lang="en-US" sz="1220" dirty="0"/>
           </a:p>
@@ -2503,7 +2503,7 @@
       </p:sp>
       <p:sp>
         <p:nvSpPr>
-          <p:cNvPr id="7" name="S00_0254_text"/>
+          <p:cNvPr id="7" name="S00_0252_text"/>
           <p:cNvSpPr/>
           <p:nvPr/>
         </p:nvSpPr>
@@ -2544,7 +2544,7 @@
       </p:sp>
       <p:sp>
         <p:nvSpPr>
-          <p:cNvPr id="8" name="S00_0255_text"/>
+          <p:cNvPr id="8" name="S00_0253_text"/>
           <p:cNvSpPr/>
           <p:nvPr/>
         </p:nvSpPr>
@@ -2585,7 +2585,7 @@
       </p:sp>
       <p:sp>
         <p:nvSpPr>
-          <p:cNvPr id="9" name="A01_0256_layer"/>
+          <p:cNvPr id="9" name="A01_0254_layer"/>
           <p:cNvSpPr/>
           <p:nvPr/>
         </p:nvSpPr>
@@ -2614,7 +2614,7 @@
       </p:sp>
       <p:sp>
         <p:nvSpPr>
-          <p:cNvPr id="10" name="A01_0257_text"/>
+          <p:cNvPr id="10" name="A01_0255_text"/>
           <p:cNvSpPr/>
           <p:nvPr/>
         </p:nvSpPr>
@@ -2655,7 +2655,7 @@
       </p:sp>
       <p:sp>
         <p:nvSpPr>
-          <p:cNvPr id="11" name="A01_0258_text"/>
+          <p:cNvPr id="11" name="A01_0256_text"/>
           <p:cNvSpPr/>
           <p:nvPr/>
         </p:nvSpPr>
@@ -2688,7 +2688,7 @@
                 <a:ea typeface="Noto Serif SC" pitchFamily="34" charset="-122"/>
                 <a:cs typeface="Noto Serif SC" pitchFamily="34" charset="-120"/>
               </a:rPr>
-              <a:t>模型听懂人话</a:t>
+              <a:t>多角色接力</a:t>
             </a:r>
             <a:endParaRPr lang="en-US" sz="2100" dirty="0"/>
           </a:p>
@@ -2696,7 +2696,7 @@
       </p:sp>
       <p:sp>
         <p:nvSpPr>
-          <p:cNvPr id="12" name="A01_0259_text"/>
+          <p:cNvPr id="12" name="A01_0257_text"/>
           <p:cNvSpPr/>
           <p:nvPr/>
         </p:nvSpPr>
@@ -2729,7 +2729,7 @@
                 <a:ea typeface="MiSans" pitchFamily="34" charset="-122"/>
                 <a:cs typeface="MiSans" pitchFamily="34" charset="-120"/>
               </a:rPr>
-              <a:t>识别用户想解决什么问题，决定由谁来处理，再把结果解释清楚。</a:t>
+              <a:t>主协调听懂目标，专业智能体各自处理课表、风险与全局洞察。</a:t>
             </a:r>
             <a:endParaRPr lang="en-US" sz="1240" dirty="0"/>
           </a:p>
@@ -2737,7 +2737,7 @@
       </p:sp>
       <p:sp>
         <p:nvSpPr>
-          <p:cNvPr id="13" name="A01_0260_text"/>
+          <p:cNvPr id="13" name="A01_0258_text"/>
           <p:cNvSpPr/>
           <p:nvPr/>
         </p:nvSpPr>
@@ -2770,7 +2770,7 @@
                 <a:ea typeface="MiSans" pitchFamily="34" charset="-122"/>
                 <a:cs typeface="MiSans" pitchFamily="34" charset="-120"/>
               </a:rPr>
-              <a:t>多智能体协作</a:t>
+              <a:t>分工有边界</a:t>
             </a:r>
             <a:endParaRPr lang="en-US" sz="1050" dirty="0"/>
           </a:p>
@@ -2778,7 +2778,7 @@
       </p:sp>
       <p:sp>
         <p:nvSpPr>
-          <p:cNvPr id="14" name="A02_0261_layer"/>
+          <p:cNvPr id="14" name="A02_0259_layer"/>
           <p:cNvSpPr/>
           <p:nvPr/>
         </p:nvSpPr>
@@ -2807,7 +2807,7 @@
       </p:sp>
       <p:sp>
         <p:nvSpPr>
-          <p:cNvPr id="15" name="A02_0262_text"/>
+          <p:cNvPr id="15" name="A02_0260_text"/>
           <p:cNvSpPr/>
           <p:nvPr/>
         </p:nvSpPr>
@@ -2848,7 +2848,7 @@
       </p:sp>
       <p:sp>
         <p:nvSpPr>
-          <p:cNvPr id="16" name="A02_0263_text"/>
+          <p:cNvPr id="16" name="A02_0261_text"/>
           <p:cNvSpPr/>
           <p:nvPr/>
         </p:nvSpPr>
@@ -2881,7 +2881,7 @@
                 <a:ea typeface="Noto Serif SC" pitchFamily="34" charset="-122"/>
                 <a:cs typeface="Noto Serif SC" pitchFamily="34" charset="-120"/>
               </a:rPr>
-              <a:t>工具把事实算清</a:t>
+              <a:t>事实单独核验</a:t>
             </a:r>
             <a:endParaRPr lang="en-US" sz="2100" dirty="0"/>
           </a:p>
@@ -2889,7 +2889,7 @@
       </p:sp>
       <p:sp>
         <p:nvSpPr>
-          <p:cNvPr id="17" name="A02_0264_text"/>
+          <p:cNvPr id="17" name="A02_0262_text"/>
           <p:cNvSpPr/>
           <p:nvPr/>
         </p:nvSpPr>
@@ -2922,7 +2922,7 @@
                 <a:ea typeface="MiSans" pitchFamily="34" charset="-122"/>
                 <a:cs typeface="MiSans" pitchFamily="34" charset="-120"/>
               </a:rPr>
-              <a:t>课表、教室、时间、容量与风险都由确定性工具查询和计算，模型不能自行猜。</a:t>
+              <a:t>课表、教室、容量与风险由 CampusTools 计算；模型不能自行补写动态事实。</a:t>
             </a:r>
             <a:endParaRPr lang="en-US" sz="1240" dirty="0"/>
           </a:p>
@@ -2930,7 +2930,7 @@
       </p:sp>
       <p:sp>
         <p:nvSpPr>
-          <p:cNvPr id="18" name="A02_0265_text"/>
+          <p:cNvPr id="18" name="A02_0263_text"/>
           <p:cNvSpPr/>
           <p:nvPr/>
         </p:nvSpPr>
@@ -2963,7 +2963,7 @@
                 <a:ea typeface="MiSans" pitchFamily="34" charset="-122"/>
                 <a:cs typeface="MiSans" pitchFamily="34" charset="-120"/>
               </a:rPr>
-              <a:t>CampusTools</a:t>
+              <a:t>结果可复核</a:t>
             </a:r>
             <a:endParaRPr lang="en-US" sz="1050" dirty="0"/>
           </a:p>
@@ -2971,7 +2971,7 @@
       </p:sp>
       <p:sp>
         <p:nvSpPr>
-          <p:cNvPr id="19" name="A03_0266_layer"/>
+          <p:cNvPr id="19" name="A03_0264_layer"/>
           <p:cNvSpPr/>
           <p:nvPr/>
         </p:nvSpPr>
@@ -3000,7 +3000,7 @@
       </p:sp>
       <p:sp>
         <p:nvSpPr>
-          <p:cNvPr id="20" name="A03_0267_text"/>
+          <p:cNvPr id="20" name="A03_0265_text"/>
           <p:cNvSpPr/>
           <p:nvPr/>
         </p:nvSpPr>
@@ -3041,7 +3041,7 @@
       </p:sp>
       <p:sp>
         <p:nvSpPr>
-          <p:cNvPr id="21" name="A03_0268_text"/>
+          <p:cNvPr id="21" name="A03_0266_text"/>
           <p:cNvSpPr/>
           <p:nvPr/>
         </p:nvSpPr>
@@ -3074,7 +3074,7 @@
                 <a:ea typeface="Noto Serif SC" pitchFamily="34" charset="-122"/>
                 <a:cs typeface="Noto Serif SC" pitchFamily="34" charset="-120"/>
               </a:rPr>
-              <a:t>结果让人放心复核</a:t>
+              <a:t>追问不用重来</a:t>
             </a:r>
             <a:endParaRPr lang="en-US" sz="2100" dirty="0"/>
           </a:p>
@@ -3082,7 +3082,7 @@
       </p:sp>
       <p:sp>
         <p:nvSpPr>
-          <p:cNvPr id="22" name="A03_0269_text"/>
+          <p:cNvPr id="22" name="A03_0267_text"/>
           <p:cNvSpPr/>
           <p:nvPr/>
         </p:nvSpPr>
@@ -3115,7 +3115,7 @@
                 <a:ea typeface="MiSans" pitchFamily="34" charset="-122"/>
                 <a:cs typeface="MiSans" pitchFamily="34" charset="-120"/>
               </a:rPr>
-              <a:t>结论、提醒和证据一起进入统一结果卡；失败时不会伪装成成功。</a:t>
+              <a:t>从“谁最忙”到“看他的课表”再到“查他的风险”，同一对象持续传递。</a:t>
             </a:r>
             <a:endParaRPr lang="en-US" sz="1240" dirty="0"/>
           </a:p>
@@ -3123,7 +3123,7 @@
       </p:sp>
       <p:sp>
         <p:nvSpPr>
-          <p:cNvPr id="23" name="A03_0270_text"/>
+          <p:cNvPr id="23" name="A03_0268_text"/>
           <p:cNvSpPr/>
           <p:nvPr/>
         </p:nvSpPr>
@@ -3156,7 +3156,7 @@
                 <a:ea typeface="MiSans" pitchFamily="34" charset="-122"/>
                 <a:cs typeface="MiSans" pitchFamily="34" charset="-120"/>
               </a:rPr>
-              <a:t>结果卡与证据</a:t>
+              <a:t>上下文连续</a:t>
             </a:r>
             <a:endParaRPr lang="en-US" sz="1050" dirty="0"/>
           </a:p>
@@ -3164,7 +3164,7 @@
       </p:sp>
       <p:sp>
         <p:nvSpPr>
-          <p:cNvPr id="24" name="A04_0271_text"/>
+          <p:cNvPr id="24" name="A04_0269_text"/>
           <p:cNvSpPr/>
           <p:nvPr/>
         </p:nvSpPr>
@@ -3915,7 +3915,7 @@
       </p:grpSpPr>
       <p:sp>
         <p:nvSpPr>
-          <p:cNvPr id="2" name="S00_0272_background-field"/>
+          <p:cNvPr id="2" name="S00_0270_background-field"/>
           <p:cNvSpPr/>
           <p:nvPr/>
         </p:nvSpPr>
@@ -3944,7 +3944,7 @@
       </p:sp>
       <p:sp>
         <p:nvSpPr>
-          <p:cNvPr id="3" name="S00_0273_background-arc"/>
+          <p:cNvPr id="3" name="S00_0271_background-arc"/>
           <p:cNvSpPr/>
           <p:nvPr/>
         </p:nvSpPr>
@@ -3973,7 +3973,7 @@
       </p:sp>
       <p:sp>
         <p:nvSpPr>
-          <p:cNvPr id="4" name="S00_0274_text"/>
+          <p:cNvPr id="4" name="S00_0272_text"/>
           <p:cNvSpPr/>
           <p:nvPr/>
         </p:nvSpPr>
@@ -4014,7 +4014,7 @@
       </p:sp>
       <p:sp>
         <p:nvSpPr>
-          <p:cNvPr id="5" name="S00_0275_text"/>
+          <p:cNvPr id="5" name="S00_0273_text"/>
           <p:cNvSpPr/>
           <p:nvPr/>
         </p:nvSpPr>
@@ -4055,7 +4055,7 @@
       </p:sp>
       <p:sp>
         <p:nvSpPr>
-          <p:cNvPr id="6" name="S00_0276_text"/>
+          <p:cNvPr id="6" name="S00_0274_text"/>
           <p:cNvSpPr/>
           <p:nvPr/>
         </p:nvSpPr>
@@ -4096,7 +4096,7 @@
       </p:sp>
       <p:sp>
         <p:nvSpPr>
-          <p:cNvPr id="7" name="S00_0277_text"/>
+          <p:cNvPr id="7" name="S00_0275_text"/>
           <p:cNvSpPr/>
           <p:nvPr/>
         </p:nvSpPr>
@@ -4137,7 +4137,7 @@
       </p:sp>
       <p:sp>
         <p:nvSpPr>
-          <p:cNvPr id="8" name="S00_0278_text"/>
+          <p:cNvPr id="8" name="S00_0276_text"/>
           <p:cNvSpPr/>
           <p:nvPr/>
         </p:nvSpPr>
@@ -4178,7 +4178,7 @@
       </p:sp>
       <p:sp>
         <p:nvSpPr>
-          <p:cNvPr id="9" name="A01_0279_text"/>
+          <p:cNvPr id="9" name="A01_0277_text"/>
           <p:cNvSpPr/>
           <p:nvPr/>
         </p:nvSpPr>
@@ -4219,7 +4219,7 @@
       </p:sp>
       <p:sp>
         <p:nvSpPr>
-          <p:cNvPr id="10" name="A01_0280_text"/>
+          <p:cNvPr id="10" name="A01_0278_text"/>
           <p:cNvSpPr/>
           <p:nvPr/>
         </p:nvSpPr>
@@ -4260,7 +4260,7 @@
       </p:sp>
       <p:sp>
         <p:nvSpPr>
-          <p:cNvPr id="11" name="A02_0281_text"/>
+          <p:cNvPr id="11" name="A02_0279_text"/>
           <p:cNvSpPr/>
           <p:nvPr/>
         </p:nvSpPr>
@@ -4293,7 +4293,7 @@
                 <a:ea typeface="MiSans" pitchFamily="34" charset="-122"/>
                 <a:cs typeface="MiSans" pitchFamily="34" charset="-120"/>
               </a:rPr>
-              <a:t>本次参赛作品在这些真实需求基础上，从“课表查询”升级为教学时空智能协同系统。</a:t>
+              <a:t>本次参赛作品在这些真实需求基础上，从课表查询升级为校园教学时空资源智能体。</a:t>
             </a:r>
             <a:endParaRPr lang="en-US" sz="1250" dirty="0"/>
           </a:p>
@@ -4301,7 +4301,7 @@
       </p:sp>
       <p:sp>
         <p:nvSpPr>
-          <p:cNvPr id="12" name="A02_0282_line"/>
+          <p:cNvPr id="12" name="A02_0280_line"/>
           <p:cNvSpPr/>
           <p:nvPr/>
         </p:nvSpPr>
@@ -4324,7 +4324,7 @@
       </p:sp>
       <p:sp>
         <p:nvSpPr>
-          <p:cNvPr id="13" name="A03_0283_text"/>
+          <p:cNvPr id="13" name="A03_0281_text"/>
           <p:cNvSpPr/>
           <p:nvPr/>
         </p:nvSpPr>
@@ -4365,7 +4365,7 @@
       </p:sp>
       <p:sp>
         <p:nvSpPr>
-          <p:cNvPr id="14" name="A03_0284_text"/>
+          <p:cNvPr id="14" name="A03_0282_text"/>
           <p:cNvSpPr/>
           <p:nvPr/>
         </p:nvSpPr>
@@ -4406,7 +4406,7 @@
       </p:sp>
       <p:sp>
         <p:nvSpPr>
-          <p:cNvPr id="15" name="A03_0285_text"/>
+          <p:cNvPr id="15" name="A03_0283_text"/>
           <p:cNvSpPr/>
           <p:nvPr/>
         </p:nvSpPr>
@@ -4447,7 +4447,7 @@
       </p:sp>
       <p:sp>
         <p:nvSpPr>
-          <p:cNvPr id="16" name="A03_0286_text"/>
+          <p:cNvPr id="16" name="A03_0284_text"/>
           <p:cNvSpPr/>
           <p:nvPr/>
         </p:nvSpPr>
@@ -4488,7 +4488,7 @@
       </p:sp>
       <p:sp>
         <p:nvSpPr>
-          <p:cNvPr id="17" name="A03_0287_text"/>
+          <p:cNvPr id="17" name="A03_0285_text"/>
           <p:cNvSpPr/>
           <p:nvPr/>
         </p:nvSpPr>
@@ -4529,7 +4529,7 @@
       </p:sp>
       <p:sp>
         <p:nvSpPr>
-          <p:cNvPr id="18" name="A03_0288_text"/>
+          <p:cNvPr id="18" name="A03_0286_text"/>
           <p:cNvSpPr/>
           <p:nvPr/>
         </p:nvSpPr>
@@ -4570,7 +4570,7 @@
       </p:sp>
       <p:sp>
         <p:nvSpPr>
-          <p:cNvPr id="19" name="A03_0289_text"/>
+          <p:cNvPr id="19" name="A03_0287_text"/>
           <p:cNvSpPr/>
           <p:nvPr/>
         </p:nvSpPr>
@@ -4611,7 +4611,7 @@
       </p:sp>
       <p:sp>
         <p:nvSpPr>
-          <p:cNvPr id="20" name="A03_0290_text"/>
+          <p:cNvPr id="20" name="A03_0288_text"/>
           <p:cNvSpPr/>
           <p:nvPr/>
         </p:nvSpPr>
@@ -4652,7 +4652,7 @@
       </p:sp>
       <p:sp>
         <p:nvSpPr>
-          <p:cNvPr id="21" name="A03_0291_text"/>
+          <p:cNvPr id="21" name="A03_0289_text"/>
           <p:cNvSpPr/>
           <p:nvPr/>
         </p:nvSpPr>
@@ -4693,7 +4693,7 @@
       </p:sp>
       <p:sp>
         <p:nvSpPr>
-          <p:cNvPr id="22" name="A03_0292_text"/>
+          <p:cNvPr id="22" name="A03_0290_text"/>
           <p:cNvSpPr/>
           <p:nvPr/>
         </p:nvSpPr>
@@ -4734,14 +4734,14 @@
       </p:sp>
       <p:sp>
         <p:nvSpPr>
-          <p:cNvPr id="23" name="A04_0293_screen-base"/>
+          <p:cNvPr id="23" name="A04_0291_screen-base"/>
           <p:cNvSpPr/>
           <p:nvPr/>
         </p:nvSpPr>
         <p:spPr>
           <a:xfrm>
             <a:off x="4261104" y="1664208"/>
-            <a:ext cx="7351776" cy="4187952"/>
+            <a:ext cx="7351776" cy="3163824"/>
           </a:xfrm>
           <a:prstGeom prst="rect">
             <a:avLst/>
@@ -4759,7 +4759,7 @@
       </p:sp>
       <p:pic>
         <p:nvPicPr>
-          <p:cNvPr id="24" name="A04_0294_screen-image" descr="competition-project\assets\portal-home-1920x1080-final.png"/>
+          <p:cNvPr id="24" name="A04_0292_screen-image" descr="competition-project\competition\final-delivery\assets\portal-home-1920x1080-final.png"/>
           <p:cNvPicPr>
             <a:picLocks noChangeAspect="1"/>
           </p:cNvPicPr>
@@ -4774,7 +4774,7 @@
         <p:spPr>
           <a:xfrm>
             <a:off x="4297680" y="1700784"/>
-            <a:ext cx="7278624" cy="4114800"/>
+            <a:ext cx="7278624" cy="3090672"/>
           </a:xfrm>
           <a:prstGeom prst="rect">
             <a:avLst/>
@@ -4783,14 +4783,14 @@
       </p:pic>
       <p:sp>
         <p:nvSpPr>
-          <p:cNvPr id="25" name="A05_0295_text"/>
-          <p:cNvSpPr/>
-          <p:nvPr/>
-        </p:nvSpPr>
-        <p:spPr>
-          <a:xfrm>
-            <a:off x="4315968" y="5961888"/>
-            <a:ext cx="7242048" cy="310896"/>
+          <p:cNvPr id="25" name="A05_0293_text"/>
+          <p:cNvSpPr/>
+          <p:nvPr/>
+        </p:nvSpPr>
+        <p:spPr>
+          <a:xfrm>
+            <a:off x="4315968" y="5074920"/>
+            <a:ext cx="347472" cy="228600"/>
           </a:xfrm>
           <a:prstGeom prst="rect">
             <a:avLst/>
@@ -4804,21 +4804,400 @@
           </a:bodyPr>
           <a:lstStyle/>
           <a:p>
-            <a:pPr marL="0" indent="0" algn="ctr">
+            <a:pPr marL="0" indent="0" algn="l">
               <a:buNone/>
             </a:pPr>
             <a:r>
-              <a:rPr lang="en-US" sz="1250" b="1" dirty="0">
+              <a:rPr lang="en-US" sz="850" b="1" dirty="0">
                 <a:solidFill>
-                  <a:srgbClr val="B83E32"/>
+                  <a:srgbClr val="E65442"/>
                 </a:solidFill>
                 <a:latin typeface="MiSans" pitchFamily="34" charset="0"/>
                 <a:ea typeface="MiSans" pitchFamily="34" charset="-122"/>
                 <a:cs typeface="MiSans" pitchFamily="34" charset="-120"/>
               </a:rPr>
-              <a:t>今天：学生查询 · 教师协同 · 教学运行辅助　→　未来：校园教学时空治理</a:t>
+              <a:t>01</a:t>
             </a:r>
-            <a:endParaRPr lang="en-US" sz="1250" dirty="0"/>
+            <a:endParaRPr lang="en-US" sz="850" dirty="0"/>
+          </a:p>
+        </p:txBody>
+      </p:sp>
+      <p:sp>
+        <p:nvSpPr>
+          <p:cNvPr id="26" name="A05_0294_line"/>
+          <p:cNvSpPr/>
+          <p:nvPr/>
+        </p:nvSpPr>
+        <p:spPr>
+          <a:xfrm>
+            <a:off x="4315968" y="5404104"/>
+            <a:ext cx="1481328" cy="0"/>
+          </a:xfrm>
+          <a:prstGeom prst="line">
+            <a:avLst/>
+          </a:prstGeom>
+          <a:noFill/>
+          <a:ln w="26670">
+            <a:solidFill>
+              <a:srgbClr val="E65442"/>
+            </a:solidFill>
+            <a:prstDash val="solid"/>
+          </a:ln>
+        </p:spPr>
+      </p:sp>
+      <p:sp>
+        <p:nvSpPr>
+          <p:cNvPr id="27" name="A05_0295_text"/>
+          <p:cNvSpPr/>
+          <p:nvPr/>
+        </p:nvSpPr>
+        <p:spPr>
+          <a:xfrm>
+            <a:off x="4315968" y="5559552"/>
+            <a:ext cx="1572768" cy="530352"/>
+          </a:xfrm>
+          <a:prstGeom prst="rect">
+            <a:avLst/>
+          </a:prstGeom>
+          <a:noFill/>
+          <a:ln/>
+        </p:spPr>
+        <p:txBody>
+          <a:bodyPr wrap="square" lIns="0" tIns="0" rIns="0" bIns="0" rtlCol="0" anchor="t">
+            <a:normAutofit/>
+          </a:bodyPr>
+          <a:lstStyle/>
+          <a:p>
+            <a:pPr marL="0" indent="0" algn="l">
+              <a:buNone/>
+            </a:pPr>
+            <a:r>
+              <a:rPr lang="en-US" sz="1020" b="1" dirty="0">
+                <a:solidFill>
+                  <a:srgbClr val="544B46"/>
+                </a:solidFill>
+                <a:latin typeface="MiSans" pitchFamily="34" charset="0"/>
+                <a:ea typeface="MiSans" pitchFamily="34" charset="-122"/>
+                <a:cs typeface="MiSans" pitchFamily="34" charset="-120"/>
+              </a:rPr>
+              <a:t>学生高频课表服务</a:t>
+            </a:r>
+            <a:endParaRPr lang="en-US" sz="1020" dirty="0"/>
+          </a:p>
+        </p:txBody>
+      </p:sp>
+      <p:sp>
+        <p:nvSpPr>
+          <p:cNvPr id="28" name="A06_0296_text"/>
+          <p:cNvSpPr/>
+          <p:nvPr/>
+        </p:nvSpPr>
+        <p:spPr>
+          <a:xfrm>
+            <a:off x="6126480" y="5074920"/>
+            <a:ext cx="347472" cy="228600"/>
+          </a:xfrm>
+          <a:prstGeom prst="rect">
+            <a:avLst/>
+          </a:prstGeom>
+          <a:noFill/>
+          <a:ln/>
+        </p:spPr>
+        <p:txBody>
+          <a:bodyPr wrap="square" lIns="0" tIns="0" rIns="0" bIns="0" rtlCol="0" anchor="ctr">
+            <a:normAutofit/>
+          </a:bodyPr>
+          <a:lstStyle/>
+          <a:p>
+            <a:pPr marL="0" indent="0" algn="l">
+              <a:buNone/>
+            </a:pPr>
+            <a:r>
+              <a:rPr lang="en-US" sz="850" b="1" dirty="0">
+                <a:solidFill>
+                  <a:srgbClr val="E65442"/>
+                </a:solidFill>
+                <a:latin typeface="MiSans" pitchFamily="34" charset="0"/>
+                <a:ea typeface="MiSans" pitchFamily="34" charset="-122"/>
+                <a:cs typeface="MiSans" pitchFamily="34" charset="-120"/>
+              </a:rPr>
+              <a:t>02</a:t>
+            </a:r>
+            <a:endParaRPr lang="en-US" sz="850" dirty="0"/>
+          </a:p>
+        </p:txBody>
+      </p:sp>
+      <p:sp>
+        <p:nvSpPr>
+          <p:cNvPr id="29" name="A06_0297_line"/>
+          <p:cNvSpPr/>
+          <p:nvPr/>
+        </p:nvSpPr>
+        <p:spPr>
+          <a:xfrm>
+            <a:off x="6126480" y="5404104"/>
+            <a:ext cx="1481328" cy="0"/>
+          </a:xfrm>
+          <a:prstGeom prst="line">
+            <a:avLst/>
+          </a:prstGeom>
+          <a:noFill/>
+          <a:ln w="26670">
+            <a:solidFill>
+              <a:srgbClr val="E65442"/>
+            </a:solidFill>
+            <a:prstDash val="solid"/>
+          </a:ln>
+        </p:spPr>
+      </p:sp>
+      <p:sp>
+        <p:nvSpPr>
+          <p:cNvPr id="30" name="A06_0298_text"/>
+          <p:cNvSpPr/>
+          <p:nvPr/>
+        </p:nvSpPr>
+        <p:spPr>
+          <a:xfrm>
+            <a:off x="6126480" y="5559552"/>
+            <a:ext cx="1572768" cy="530352"/>
+          </a:xfrm>
+          <a:prstGeom prst="rect">
+            <a:avLst/>
+          </a:prstGeom>
+          <a:noFill/>
+          <a:ln/>
+        </p:spPr>
+        <p:txBody>
+          <a:bodyPr wrap="square" lIns="0" tIns="0" rIns="0" bIns="0" rtlCol="0" anchor="t">
+            <a:normAutofit/>
+          </a:bodyPr>
+          <a:lstStyle/>
+          <a:p>
+            <a:pPr marL="0" indent="0" algn="l">
+              <a:buNone/>
+            </a:pPr>
+            <a:r>
+              <a:rPr lang="en-US" sz="1020" b="1" dirty="0">
+                <a:solidFill>
+                  <a:srgbClr val="544B46"/>
+                </a:solidFill>
+                <a:latin typeface="MiSans" pitchFamily="34" charset="0"/>
+                <a:ea typeface="MiSans" pitchFamily="34" charset="-122"/>
+                <a:cs typeface="MiSans" pitchFamily="34" charset="-120"/>
+              </a:rPr>
+              <a:t>教师协同与资源推荐</a:t>
+            </a:r>
+            <a:endParaRPr lang="en-US" sz="1020" dirty="0"/>
+          </a:p>
+        </p:txBody>
+      </p:sp>
+      <p:sp>
+        <p:nvSpPr>
+          <p:cNvPr id="31" name="A07_0299_text"/>
+          <p:cNvSpPr/>
+          <p:nvPr/>
+        </p:nvSpPr>
+        <p:spPr>
+          <a:xfrm>
+            <a:off x="7936992" y="5074920"/>
+            <a:ext cx="347472" cy="228600"/>
+          </a:xfrm>
+          <a:prstGeom prst="rect">
+            <a:avLst/>
+          </a:prstGeom>
+          <a:noFill/>
+          <a:ln/>
+        </p:spPr>
+        <p:txBody>
+          <a:bodyPr wrap="square" lIns="0" tIns="0" rIns="0" bIns="0" rtlCol="0" anchor="ctr">
+            <a:normAutofit/>
+          </a:bodyPr>
+          <a:lstStyle/>
+          <a:p>
+            <a:pPr marL="0" indent="0" algn="l">
+              <a:buNone/>
+            </a:pPr>
+            <a:r>
+              <a:rPr lang="en-US" sz="850" b="1" dirty="0">
+                <a:solidFill>
+                  <a:srgbClr val="237F69"/>
+                </a:solidFill>
+                <a:latin typeface="MiSans" pitchFamily="34" charset="0"/>
+                <a:ea typeface="MiSans" pitchFamily="34" charset="-122"/>
+                <a:cs typeface="MiSans" pitchFamily="34" charset="-120"/>
+              </a:rPr>
+              <a:t>03</a:t>
+            </a:r>
+            <a:endParaRPr lang="en-US" sz="850" dirty="0"/>
+          </a:p>
+        </p:txBody>
+      </p:sp>
+      <p:sp>
+        <p:nvSpPr>
+          <p:cNvPr id="32" name="A07_0300_line"/>
+          <p:cNvSpPr/>
+          <p:nvPr/>
+        </p:nvSpPr>
+        <p:spPr>
+          <a:xfrm>
+            <a:off x="7936992" y="5404104"/>
+            <a:ext cx="1481328" cy="0"/>
+          </a:xfrm>
+          <a:prstGeom prst="line">
+            <a:avLst/>
+          </a:prstGeom>
+          <a:noFill/>
+          <a:ln w="26670">
+            <a:solidFill>
+              <a:srgbClr val="237F69"/>
+            </a:solidFill>
+            <a:prstDash val="solid"/>
+          </a:ln>
+        </p:spPr>
+      </p:sp>
+      <p:sp>
+        <p:nvSpPr>
+          <p:cNvPr id="33" name="A07_0301_text"/>
+          <p:cNvSpPr/>
+          <p:nvPr/>
+        </p:nvSpPr>
+        <p:spPr>
+          <a:xfrm>
+            <a:off x="7936992" y="5559552"/>
+            <a:ext cx="1572768" cy="530352"/>
+          </a:xfrm>
+          <a:prstGeom prst="rect">
+            <a:avLst/>
+          </a:prstGeom>
+          <a:noFill/>
+          <a:ln/>
+        </p:spPr>
+        <p:txBody>
+          <a:bodyPr wrap="square" lIns="0" tIns="0" rIns="0" bIns="0" rtlCol="0" anchor="t">
+            <a:normAutofit/>
+          </a:bodyPr>
+          <a:lstStyle/>
+          <a:p>
+            <a:pPr marL="0" indent="0" algn="l">
+              <a:buNone/>
+            </a:pPr>
+            <a:r>
+              <a:rPr lang="en-US" sz="1020" b="1" dirty="0">
+                <a:solidFill>
+                  <a:srgbClr val="544B46"/>
+                </a:solidFill>
+                <a:latin typeface="MiSans" pitchFamily="34" charset="0"/>
+                <a:ea typeface="MiSans" pitchFamily="34" charset="-122"/>
+                <a:cs typeface="MiSans" pitchFamily="34" charset="-120"/>
+              </a:rPr>
+              <a:t>教学管理风险预警</a:t>
+            </a:r>
+            <a:endParaRPr lang="en-US" sz="1020" dirty="0"/>
+          </a:p>
+        </p:txBody>
+      </p:sp>
+      <p:sp>
+        <p:nvSpPr>
+          <p:cNvPr id="34" name="A08_0302_text"/>
+          <p:cNvSpPr/>
+          <p:nvPr/>
+        </p:nvSpPr>
+        <p:spPr>
+          <a:xfrm>
+            <a:off x="9747504" y="5074920"/>
+            <a:ext cx="347472" cy="228600"/>
+          </a:xfrm>
+          <a:prstGeom prst="rect">
+            <a:avLst/>
+          </a:prstGeom>
+          <a:noFill/>
+          <a:ln/>
+        </p:spPr>
+        <p:txBody>
+          <a:bodyPr wrap="square" lIns="0" tIns="0" rIns="0" bIns="0" rtlCol="0" anchor="ctr">
+            <a:normAutofit/>
+          </a:bodyPr>
+          <a:lstStyle/>
+          <a:p>
+            <a:pPr marL="0" indent="0" algn="l">
+              <a:buNone/>
+            </a:pPr>
+            <a:r>
+              <a:rPr lang="en-US" sz="850" b="1" dirty="0">
+                <a:solidFill>
+                  <a:srgbClr val="237F69"/>
+                </a:solidFill>
+                <a:latin typeface="MiSans" pitchFamily="34" charset="0"/>
+                <a:ea typeface="MiSans" pitchFamily="34" charset="-122"/>
+                <a:cs typeface="MiSans" pitchFamily="34" charset="-120"/>
+              </a:rPr>
+              <a:t>04</a:t>
+            </a:r>
+            <a:endParaRPr lang="en-US" sz="850" dirty="0"/>
+          </a:p>
+        </p:txBody>
+      </p:sp>
+      <p:sp>
+        <p:nvSpPr>
+          <p:cNvPr id="35" name="A08_0303_line"/>
+          <p:cNvSpPr/>
+          <p:nvPr/>
+        </p:nvSpPr>
+        <p:spPr>
+          <a:xfrm>
+            <a:off x="9747504" y="5404104"/>
+            <a:ext cx="1481328" cy="0"/>
+          </a:xfrm>
+          <a:prstGeom prst="line">
+            <a:avLst/>
+          </a:prstGeom>
+          <a:noFill/>
+          <a:ln w="26670">
+            <a:solidFill>
+              <a:srgbClr val="237F69"/>
+            </a:solidFill>
+            <a:prstDash val="solid"/>
+          </a:ln>
+        </p:spPr>
+      </p:sp>
+      <p:sp>
+        <p:nvSpPr>
+          <p:cNvPr id="36" name="A08_0304_text"/>
+          <p:cNvSpPr/>
+          <p:nvPr/>
+        </p:nvSpPr>
+        <p:spPr>
+          <a:xfrm>
+            <a:off x="9747504" y="5559552"/>
+            <a:ext cx="1572768" cy="530352"/>
+          </a:xfrm>
+          <a:prstGeom prst="rect">
+            <a:avLst/>
+          </a:prstGeom>
+          <a:noFill/>
+          <a:ln/>
+        </p:spPr>
+        <p:txBody>
+          <a:bodyPr wrap="square" lIns="0" tIns="0" rIns="0" bIns="0" rtlCol="0" anchor="t">
+            <a:normAutofit/>
+          </a:bodyPr>
+          <a:lstStyle/>
+          <a:p>
+            <a:pPr marL="0" indent="0" algn="l">
+              <a:buNone/>
+            </a:pPr>
+            <a:r>
+              <a:rPr lang="en-US" sz="1020" b="1" dirty="0">
+                <a:solidFill>
+                  <a:srgbClr val="544B46"/>
+                </a:solidFill>
+                <a:latin typeface="MiSans" pitchFamily="34" charset="0"/>
+                <a:ea typeface="MiSans" pitchFamily="34" charset="-122"/>
+                <a:cs typeface="MiSans" pitchFamily="34" charset="-120"/>
+              </a:rPr>
+              <a:t>教学时空数字化治理</a:t>
+            </a:r>
+            <a:endParaRPr lang="en-US" sz="1020" dirty="0"/>
           </a:p>
         </p:txBody>
       </p:sp>
@@ -5508,6 +5887,445 @@
                                         <p:cTn id="63" dur="380"/>
                                         <p:tgtEl>
                                           <p:spTgt spid="25"/>
+                                        </p:tgtEl>
+                                      </p:cBhvr>
+                                    </p:animEffect>
+                                  </p:childTnLst>
+                                </p:cTn>
+                              </p:par>
+                              <p:par>
+                                <p:cTn id="64" presetID="10" presetClass="entr" presetSubtype="0" fill="hold" nodeType="withEffect">
+                                  <p:stCondLst>
+                                    <p:cond delay="0"/>
+                                  </p:stCondLst>
+                                  <p:childTnLst>
+                                    <p:set>
+                                      <p:cBhvr>
+                                        <p:cTn id="65" dur="1" fill="hold">
+                                          <p:stCondLst>
+                                            <p:cond delay="0"/>
+                                          </p:stCondLst>
+                                        </p:cTn>
+                                        <p:tgtEl>
+                                          <p:spTgt spid="26"/>
+                                        </p:tgtEl>
+                                        <p:attrNameLst>
+                                          <p:attrName>style.visibility</p:attrName>
+                                        </p:attrNameLst>
+                                      </p:cBhvr>
+                                      <p:to>
+                                        <p:strVal val="visible"/>
+                                      </p:to>
+                                    </p:set>
+                                    <p:animEffect transition="in" filter="fade">
+                                      <p:cBhvr>
+                                        <p:cTn id="66" dur="380"/>
+                                        <p:tgtEl>
+                                          <p:spTgt spid="26"/>
+                                        </p:tgtEl>
+                                      </p:cBhvr>
+                                    </p:animEffect>
+                                  </p:childTnLst>
+                                </p:cTn>
+                              </p:par>
+                              <p:par>
+                                <p:cTn id="67" presetID="10" presetClass="entr" presetSubtype="0" fill="hold" grpId="0" nodeType="withEffect">
+                                  <p:stCondLst>
+                                    <p:cond delay="0"/>
+                                  </p:stCondLst>
+                                  <p:childTnLst>
+                                    <p:set>
+                                      <p:cBhvr>
+                                        <p:cTn id="68" dur="1" fill="hold">
+                                          <p:stCondLst>
+                                            <p:cond delay="0"/>
+                                          </p:stCondLst>
+                                        </p:cTn>
+                                        <p:tgtEl>
+                                          <p:spTgt spid="27"/>
+                                        </p:tgtEl>
+                                        <p:attrNameLst>
+                                          <p:attrName>style.visibility</p:attrName>
+                                        </p:attrNameLst>
+                                      </p:cBhvr>
+                                      <p:to>
+                                        <p:strVal val="visible"/>
+                                      </p:to>
+                                    </p:set>
+                                    <p:animEffect transition="in" filter="fade">
+                                      <p:cBhvr>
+                                        <p:cTn id="69" dur="380"/>
+                                        <p:tgtEl>
+                                          <p:spTgt spid="27"/>
+                                        </p:tgtEl>
+                                      </p:cBhvr>
+                                    </p:animEffect>
+                                  </p:childTnLst>
+                                </p:cTn>
+                              </p:par>
+                            </p:childTnLst>
+                          </p:cTn>
+                        </p:par>
+                      </p:childTnLst>
+                    </p:cTn>
+                  </p:par>
+                  <p:par>
+                    <p:cTn id="70" fill="hold">
+                      <p:stCondLst>
+                        <p:cond delay="indefinite"/>
+                      </p:stCondLst>
+                      <p:childTnLst>
+                        <p:par>
+                          <p:cTn id="71" fill="hold">
+                            <p:stCondLst>
+                              <p:cond delay="0"/>
+                            </p:stCondLst>
+                            <p:childTnLst>
+                              <p:par>
+                                <p:cTn id="72" presetID="10" presetClass="entr" presetSubtype="0" fill="hold" grpId="0" nodeType="clickEffect">
+                                  <p:stCondLst>
+                                    <p:cond delay="0"/>
+                                  </p:stCondLst>
+                                  <p:childTnLst>
+                                    <p:set>
+                                      <p:cBhvr>
+                                        <p:cTn id="73" dur="1" fill="hold">
+                                          <p:stCondLst>
+                                            <p:cond delay="0"/>
+                                          </p:stCondLst>
+                                        </p:cTn>
+                                        <p:tgtEl>
+                                          <p:spTgt spid="28"/>
+                                        </p:tgtEl>
+                                        <p:attrNameLst>
+                                          <p:attrName>style.visibility</p:attrName>
+                                        </p:attrNameLst>
+                                      </p:cBhvr>
+                                      <p:to>
+                                        <p:strVal val="visible"/>
+                                      </p:to>
+                                    </p:set>
+                                    <p:animEffect transition="in" filter="fade">
+                                      <p:cBhvr>
+                                        <p:cTn id="74" dur="380"/>
+                                        <p:tgtEl>
+                                          <p:spTgt spid="28"/>
+                                        </p:tgtEl>
+                                      </p:cBhvr>
+                                    </p:animEffect>
+                                  </p:childTnLst>
+                                </p:cTn>
+                              </p:par>
+                              <p:par>
+                                <p:cTn id="75" presetID="10" presetClass="entr" presetSubtype="0" fill="hold" nodeType="withEffect">
+                                  <p:stCondLst>
+                                    <p:cond delay="0"/>
+                                  </p:stCondLst>
+                                  <p:childTnLst>
+                                    <p:set>
+                                      <p:cBhvr>
+                                        <p:cTn id="76" dur="1" fill="hold">
+                                          <p:stCondLst>
+                                            <p:cond delay="0"/>
+                                          </p:stCondLst>
+                                        </p:cTn>
+                                        <p:tgtEl>
+                                          <p:spTgt spid="29"/>
+                                        </p:tgtEl>
+                                        <p:attrNameLst>
+                                          <p:attrName>style.visibility</p:attrName>
+                                        </p:attrNameLst>
+                                      </p:cBhvr>
+                                      <p:to>
+                                        <p:strVal val="visible"/>
+                                      </p:to>
+                                    </p:set>
+                                    <p:animEffect transition="in" filter="fade">
+                                      <p:cBhvr>
+                                        <p:cTn id="77" dur="380"/>
+                                        <p:tgtEl>
+                                          <p:spTgt spid="29"/>
+                                        </p:tgtEl>
+                                      </p:cBhvr>
+                                    </p:animEffect>
+                                  </p:childTnLst>
+                                </p:cTn>
+                              </p:par>
+                              <p:par>
+                                <p:cTn id="78" presetID="10" presetClass="entr" presetSubtype="0" fill="hold" grpId="0" nodeType="withEffect">
+                                  <p:stCondLst>
+                                    <p:cond delay="0"/>
+                                  </p:stCondLst>
+                                  <p:childTnLst>
+                                    <p:set>
+                                      <p:cBhvr>
+                                        <p:cTn id="79" dur="1" fill="hold">
+                                          <p:stCondLst>
+                                            <p:cond delay="0"/>
+                                          </p:stCondLst>
+                                        </p:cTn>
+                                        <p:tgtEl>
+                                          <p:spTgt spid="30"/>
+                                        </p:tgtEl>
+                                        <p:attrNameLst>
+                                          <p:attrName>style.visibility</p:attrName>
+                                        </p:attrNameLst>
+                                      </p:cBhvr>
+                                      <p:to>
+                                        <p:strVal val="visible"/>
+                                      </p:to>
+                                    </p:set>
+                                    <p:animEffect transition="in" filter="fade">
+                                      <p:cBhvr>
+                                        <p:cTn id="80" dur="380"/>
+                                        <p:tgtEl>
+                                          <p:spTgt spid="30"/>
+                                        </p:tgtEl>
+                                      </p:cBhvr>
+                                    </p:animEffect>
+                                  </p:childTnLst>
+                                </p:cTn>
+                              </p:par>
+                            </p:childTnLst>
+                          </p:cTn>
+                        </p:par>
+                      </p:childTnLst>
+                    </p:cTn>
+                  </p:par>
+                  <p:par>
+                    <p:cTn id="81" fill="hold">
+                      <p:stCondLst>
+                        <p:cond delay="indefinite"/>
+                      </p:stCondLst>
+                      <p:childTnLst>
+                        <p:par>
+                          <p:cTn id="82" fill="hold">
+                            <p:stCondLst>
+                              <p:cond delay="0"/>
+                            </p:stCondLst>
+                            <p:childTnLst>
+                              <p:par>
+                                <p:cTn id="83" presetID="10" presetClass="entr" presetSubtype="0" fill="hold" grpId="0" nodeType="clickEffect">
+                                  <p:stCondLst>
+                                    <p:cond delay="0"/>
+                                  </p:stCondLst>
+                                  <p:childTnLst>
+                                    <p:set>
+                                      <p:cBhvr>
+                                        <p:cTn id="84" dur="1" fill="hold">
+                                          <p:stCondLst>
+                                            <p:cond delay="0"/>
+                                          </p:stCondLst>
+                                        </p:cTn>
+                                        <p:tgtEl>
+                                          <p:spTgt spid="31"/>
+                                        </p:tgtEl>
+                                        <p:attrNameLst>
+                                          <p:attrName>style.visibility</p:attrName>
+                                        </p:attrNameLst>
+                                      </p:cBhvr>
+                                      <p:to>
+                                        <p:strVal val="visible"/>
+                                      </p:to>
+                                    </p:set>
+                                    <p:animEffect transition="in" filter="fade">
+                                      <p:cBhvr>
+                                        <p:cTn id="85" dur="380"/>
+                                        <p:tgtEl>
+                                          <p:spTgt spid="31"/>
+                                        </p:tgtEl>
+                                      </p:cBhvr>
+                                    </p:animEffect>
+                                  </p:childTnLst>
+                                </p:cTn>
+                              </p:par>
+                              <p:par>
+                                <p:cTn id="86" presetID="10" presetClass="entr" presetSubtype="0" fill="hold" nodeType="withEffect">
+                                  <p:stCondLst>
+                                    <p:cond delay="0"/>
+                                  </p:stCondLst>
+                                  <p:childTnLst>
+                                    <p:set>
+                                      <p:cBhvr>
+                                        <p:cTn id="87" dur="1" fill="hold">
+                                          <p:stCondLst>
+                                            <p:cond delay="0"/>
+                                          </p:stCondLst>
+                                        </p:cTn>
+                                        <p:tgtEl>
+                                          <p:spTgt spid="32"/>
+                                        </p:tgtEl>
+                                        <p:attrNameLst>
+                                          <p:attrName>style.visibility</p:attrName>
+                                        </p:attrNameLst>
+                                      </p:cBhvr>
+                                      <p:to>
+                                        <p:strVal val="visible"/>
+                                      </p:to>
+                                    </p:set>
+                                    <p:animEffect transition="in" filter="fade">
+                                      <p:cBhvr>
+                                        <p:cTn id="88" dur="380"/>
+                                        <p:tgtEl>
+                                          <p:spTgt spid="32"/>
+                                        </p:tgtEl>
+                                      </p:cBhvr>
+                                    </p:animEffect>
+                                  </p:childTnLst>
+                                </p:cTn>
+                              </p:par>
+                              <p:par>
+                                <p:cTn id="89" presetID="10" presetClass="entr" presetSubtype="0" fill="hold" grpId="0" nodeType="withEffect">
+                                  <p:stCondLst>
+                                    <p:cond delay="0"/>
+                                  </p:stCondLst>
+                                  <p:childTnLst>
+                                    <p:set>
+                                      <p:cBhvr>
+                                        <p:cTn id="90" dur="1" fill="hold">
+                                          <p:stCondLst>
+                                            <p:cond delay="0"/>
+                                          </p:stCondLst>
+                                        </p:cTn>
+                                        <p:tgtEl>
+                                          <p:spTgt spid="33"/>
+                                        </p:tgtEl>
+                                        <p:attrNameLst>
+                                          <p:attrName>style.visibility</p:attrName>
+                                        </p:attrNameLst>
+                                      </p:cBhvr>
+                                      <p:to>
+                                        <p:strVal val="visible"/>
+                                      </p:to>
+                                    </p:set>
+                                    <p:animEffect transition="in" filter="fade">
+                                      <p:cBhvr>
+                                        <p:cTn id="91" dur="380"/>
+                                        <p:tgtEl>
+                                          <p:spTgt spid="33"/>
+                                        </p:tgtEl>
+                                      </p:cBhvr>
+                                    </p:animEffect>
+                                  </p:childTnLst>
+                                </p:cTn>
+                              </p:par>
+                            </p:childTnLst>
+                          </p:cTn>
+                        </p:par>
+                      </p:childTnLst>
+                    </p:cTn>
+                  </p:par>
+                  <p:par>
+                    <p:cTn id="92" fill="hold">
+                      <p:stCondLst>
+                        <p:cond delay="indefinite"/>
+                      </p:stCondLst>
+                      <p:childTnLst>
+                        <p:par>
+                          <p:cTn id="93" fill="hold">
+                            <p:stCondLst>
+                              <p:cond delay="0"/>
+                            </p:stCondLst>
+                            <p:childTnLst>
+                              <p:par>
+                                <p:cTn id="94" presetID="10" presetClass="entr" presetSubtype="0" fill="hold" grpId="0" nodeType="clickEffect">
+                                  <p:stCondLst>
+                                    <p:cond delay="0"/>
+                                  </p:stCondLst>
+                                  <p:childTnLst>
+                                    <p:set>
+                                      <p:cBhvr>
+                                        <p:cTn id="95" dur="1" fill="hold">
+                                          <p:stCondLst>
+                                            <p:cond delay="0"/>
+                                          </p:stCondLst>
+                                        </p:cTn>
+                                        <p:tgtEl>
+                                          <p:spTgt spid="34"/>
+                                        </p:tgtEl>
+                                        <p:attrNameLst>
+                                          <p:attrName>style.visibility</p:attrName>
+                                        </p:attrNameLst>
+                                      </p:cBhvr>
+                                      <p:to>
+                                        <p:strVal val="visible"/>
+                                      </p:to>
+                                    </p:set>
+                                    <p:animEffect transition="in" filter="fade">
+                                      <p:cBhvr>
+                                        <p:cTn id="96" dur="380"/>
+                                        <p:tgtEl>
+                                          <p:spTgt spid="34"/>
+                                        </p:tgtEl>
+                                      </p:cBhvr>
+                                    </p:animEffect>
+                                  </p:childTnLst>
+                                </p:cTn>
+                              </p:par>
+                              <p:par>
+                                <p:cTn id="97" presetID="10" presetClass="entr" presetSubtype="0" fill="hold" nodeType="withEffect">
+                                  <p:stCondLst>
+                                    <p:cond delay="0"/>
+                                  </p:stCondLst>
+                                  <p:childTnLst>
+                                    <p:set>
+                                      <p:cBhvr>
+                                        <p:cTn id="98" dur="1" fill="hold">
+                                          <p:stCondLst>
+                                            <p:cond delay="0"/>
+                                          </p:stCondLst>
+                                        </p:cTn>
+                                        <p:tgtEl>
+                                          <p:spTgt spid="35"/>
+                                        </p:tgtEl>
+                                        <p:attrNameLst>
+                                          <p:attrName>style.visibility</p:attrName>
+                                        </p:attrNameLst>
+                                      </p:cBhvr>
+                                      <p:to>
+                                        <p:strVal val="visible"/>
+                                      </p:to>
+                                    </p:set>
+                                    <p:animEffect transition="in" filter="fade">
+                                      <p:cBhvr>
+                                        <p:cTn id="99" dur="380"/>
+                                        <p:tgtEl>
+                                          <p:spTgt spid="35"/>
+                                        </p:tgtEl>
+                                      </p:cBhvr>
+                                    </p:animEffect>
+                                  </p:childTnLst>
+                                </p:cTn>
+                              </p:par>
+                              <p:par>
+                                <p:cTn id="100" presetID="10" presetClass="entr" presetSubtype="0" fill="hold" grpId="0" nodeType="withEffect">
+                                  <p:stCondLst>
+                                    <p:cond delay="0"/>
+                                  </p:stCondLst>
+                                  <p:childTnLst>
+                                    <p:set>
+                                      <p:cBhvr>
+                                        <p:cTn id="101" dur="1" fill="hold">
+                                          <p:stCondLst>
+                                            <p:cond delay="0"/>
+                                          </p:stCondLst>
+                                        </p:cTn>
+                                        <p:tgtEl>
+                                          <p:spTgt spid="36"/>
+                                        </p:tgtEl>
+                                        <p:attrNameLst>
+                                          <p:attrName>style.visibility</p:attrName>
+                                        </p:attrNameLst>
+                                      </p:cBhvr>
+                                      <p:to>
+                                        <p:strVal val="visible"/>
+                                      </p:to>
+                                    </p:set>
+                                    <p:animEffect transition="in" filter="fade">
+                                      <p:cBhvr>
+                                        <p:cTn id="102" dur="380"/>
+                                        <p:tgtEl>
+                                          <p:spTgt spid="36"/>
                                         </p:tgtEl>
                                       </p:cBhvr>
                                     </p:animEffect>
@@ -5556,6 +6374,13 @@
       <p:bldP spid="21" grpId="0" animBg="1"/>
       <p:bldP spid="22" grpId="0" animBg="1"/>
       <p:bldP spid="25" grpId="0" animBg="1"/>
+      <p:bldP spid="27" grpId="0" animBg="1"/>
+      <p:bldP spid="28" grpId="0" animBg="1"/>
+      <p:bldP spid="30" grpId="0" animBg="1"/>
+      <p:bldP spid="31" grpId="0" animBg="1"/>
+      <p:bldP spid="33" grpId="0" animBg="1"/>
+      <p:bldP spid="34" grpId="0" animBg="1"/>
+      <p:bldP spid="36" grpId="0" animBg="1"/>
     </p:bldLst>
   </p:timing>
 </p:sld>
@@ -5588,7 +6413,7 @@
       </p:grpSpPr>
       <p:sp>
         <p:nvSpPr>
-          <p:cNvPr id="2" name="S00_0296_background-field"/>
+          <p:cNvPr id="2" name="S00_0305_background-field"/>
           <p:cNvSpPr/>
           <p:nvPr/>
         </p:nvSpPr>
@@ -5617,7 +6442,7 @@
       </p:sp>
       <p:sp>
         <p:nvSpPr>
-          <p:cNvPr id="3" name="S00_0297_background-field"/>
+          <p:cNvPr id="3" name="S00_0306_background-field"/>
           <p:cNvSpPr/>
           <p:nvPr/>
         </p:nvSpPr>
@@ -5646,7 +6471,7 @@
       </p:sp>
       <p:sp>
         <p:nvSpPr>
-          <p:cNvPr id="4" name="S00_0298_text"/>
+          <p:cNvPr id="4" name="S00_0307_text"/>
           <p:cNvSpPr/>
           <p:nvPr/>
         </p:nvSpPr>
@@ -5687,7 +6512,7 @@
       </p:sp>
       <p:sp>
         <p:nvSpPr>
-          <p:cNvPr id="5" name="A01_0299_text"/>
+          <p:cNvPr id="5" name="A01_0308_text"/>
           <p:cNvSpPr/>
           <p:nvPr/>
         </p:nvSpPr>
@@ -5745,7 +6570,7 @@
       </p:sp>
       <p:sp>
         <p:nvSpPr>
-          <p:cNvPr id="6" name="A01_0300_text"/>
+          <p:cNvPr id="6" name="A01_0309_text"/>
           <p:cNvSpPr/>
           <p:nvPr/>
         </p:nvSpPr>
@@ -5786,7 +6611,7 @@
       </p:sp>
       <p:sp>
         <p:nvSpPr>
-          <p:cNvPr id="7" name="A02_0301_screen-base"/>
+          <p:cNvPr id="7" name="A02_0310_screen-base"/>
           <p:cNvSpPr/>
           <p:nvPr/>
         </p:nvSpPr>
@@ -5811,7 +6636,7 @@
       </p:sp>
       <p:pic>
         <p:nvPicPr>
-          <p:cNvPr id="8" name="A02_0302_screen-image" descr="competition-project\assets\portal-home-1920x1080-final.png"/>
+          <p:cNvPr id="8" name="A02_0311_screen-image" descr="competition-project\competition\final-delivery\assets\portal-home-1920x1080-final.png"/>
           <p:cNvPicPr>
             <a:picLocks noChangeAspect="1"/>
           </p:cNvPicPr>
@@ -5835,7 +6660,7 @@
       </p:pic>
       <p:sp>
         <p:nvSpPr>
-          <p:cNvPr id="9" name="A03_0303_screen-base"/>
+          <p:cNvPr id="9" name="A03_0312_screen-base"/>
           <p:cNvSpPr/>
           <p:nvPr/>
         </p:nvSpPr>
@@ -5860,7 +6685,7 @@
       </p:sp>
       <p:pic>
         <p:nvPicPr>
-          <p:cNvPr id="10" name="A03_0304_screen-image" descr="competition-project\assets\portal-capability-1920x1080-final.png"/>
+          <p:cNvPr id="10" name="A03_0313_screen-image" descr="competition-project\competition\final-delivery\assets\portal-capability-1920x1080-final.png"/>
           <p:cNvPicPr>
             <a:picLocks noChangeAspect="1"/>
           </p:cNvPicPr>
@@ -5884,7 +6709,7 @@
       </p:pic>
       <p:sp>
         <p:nvSpPr>
-          <p:cNvPr id="11" name="A04_0305_screen-base"/>
+          <p:cNvPr id="11" name="A04_0314_screen-base"/>
           <p:cNvSpPr/>
           <p:nvPr/>
         </p:nvSpPr>
@@ -5909,7 +6734,7 @@
       </p:sp>
       <p:pic>
         <p:nvPicPr>
-          <p:cNvPr id="12" name="A04_0306_screen-image" descr="competition-project\assets\portal-verified-widget-1920x1080-final.png"/>
+          <p:cNvPr id="12" name="A04_0315_screen-image" descr="competition-project\competition\final-delivery\assets\portal-verified-widget-1920x1080-final.png"/>
           <p:cNvPicPr>
             <a:picLocks noChangeAspect="1"/>
           </p:cNvPicPr>
@@ -5933,7 +6758,7 @@
       </p:pic>
       <p:sp>
         <p:nvSpPr>
-          <p:cNvPr id="13" name="A05_0307_text"/>
+          <p:cNvPr id="13" name="A05_0316_text"/>
           <p:cNvSpPr/>
           <p:nvPr/>
         </p:nvSpPr>
@@ -5974,7 +6799,7 @@
       </p:sp>
       <p:sp>
         <p:nvSpPr>
-          <p:cNvPr id="14" name="A05_0308_text"/>
+          <p:cNvPr id="14" name="A05_0317_text"/>
           <p:cNvSpPr/>
           <p:nvPr/>
         </p:nvSpPr>
@@ -6032,7 +6857,7 @@
       </p:sp>
       <p:sp>
         <p:nvSpPr>
-          <p:cNvPr id="15" name="A06_0309_text"/>
+          <p:cNvPr id="15" name="A06_0318_text"/>
           <p:cNvSpPr/>
           <p:nvPr/>
         </p:nvSpPr>
@@ -6073,7 +6898,7 @@
       </p:sp>
       <p:sp>
         <p:nvSpPr>
-          <p:cNvPr id="16" name="A06_0310_text"/>
+          <p:cNvPr id="16" name="A06_0319_text"/>
           <p:cNvSpPr/>
           <p:nvPr/>
         </p:nvSpPr>
@@ -6131,7 +6956,7 @@
       </p:sp>
       <p:sp>
         <p:nvSpPr>
-          <p:cNvPr id="17" name="A07_0311_text"/>
+          <p:cNvPr id="17" name="A07_0320_text"/>
           <p:cNvSpPr/>
           <p:nvPr/>
         </p:nvSpPr>
@@ -6172,7 +6997,7 @@
       </p:sp>
       <p:sp>
         <p:nvSpPr>
-          <p:cNvPr id="18" name="A07_0312_text"/>
+          <p:cNvPr id="18" name="A07_0321_text"/>
           <p:cNvSpPr/>
           <p:nvPr/>
         </p:nvSpPr>
@@ -6230,7 +7055,7 @@
       </p:sp>
       <p:pic>
         <p:nvPicPr>
-          <p:cNvPr id="19" name="A08_0313_qr" descr="competition-project\assets\在线演示二维码.png"/>
+          <p:cNvPr id="19" name="A08_0322_qr" descr="competition-project\competition\final-delivery\assets\在线演示二维码.png"/>
           <p:cNvPicPr>
             <a:picLocks noChangeAspect="1"/>
           </p:cNvPicPr>
@@ -6254,7 +7079,7 @@
       </p:pic>
       <p:sp>
         <p:nvSpPr>
-          <p:cNvPr id="20" name="A08_0314_text"/>
+          <p:cNvPr id="20" name="A08_0323_text"/>
           <p:cNvSpPr/>
           <p:nvPr/>
         </p:nvSpPr>
@@ -6295,7 +7120,7 @@
       </p:sp>
       <p:sp>
         <p:nvSpPr>
-          <p:cNvPr id="21" name="A08_0315_text"/>
+          <p:cNvPr id="21" name="A08_0324_text"/>
           <p:cNvSpPr/>
           <p:nvPr/>
         </p:nvSpPr>
@@ -6336,7 +7161,7 @@
       </p:sp>
       <p:sp>
         <p:nvSpPr>
-          <p:cNvPr id="22" name="A09_0316_text"/>
+          <p:cNvPr id="22" name="A09_0325_text"/>
           <p:cNvSpPr/>
           <p:nvPr/>
         </p:nvSpPr>
@@ -6377,7 +7202,7 @@
       </p:sp>
       <p:sp>
         <p:nvSpPr>
-          <p:cNvPr id="23" name="A09_0317_text"/>
+          <p:cNvPr id="23" name="A09_0326_text"/>
           <p:cNvSpPr/>
           <p:nvPr/>
         </p:nvSpPr>
@@ -6418,7 +7243,7 @@
       </p:sp>
       <p:sp>
         <p:nvSpPr>
-          <p:cNvPr id="24" name="S00_0318_text"/>
+          <p:cNvPr id="24" name="S00_0327_text"/>
           <p:cNvSpPr/>
           <p:nvPr/>
         </p:nvSpPr>
@@ -6459,7 +7284,7 @@
       </p:sp>
       <p:sp>
         <p:nvSpPr>
-          <p:cNvPr id="25" name="S00_0319_text"/>
+          <p:cNvPr id="25" name="S00_0328_text"/>
           <p:cNvSpPr/>
           <p:nvPr/>
         </p:nvSpPr>
@@ -13143,13 +13968,54 @@
       </p:sp>
       <p:sp>
         <p:nvSpPr>
-          <p:cNvPr id="35" name="A08_0110_label-bg"/>
-          <p:cNvSpPr/>
-          <p:nvPr/>
-        </p:nvSpPr>
-        <p:spPr>
-          <a:xfrm>
-            <a:off x="7370064" y="5632704"/>
+          <p:cNvPr id="35" name="A08_0110_text"/>
+          <p:cNvSpPr/>
+          <p:nvPr/>
+        </p:nvSpPr>
+        <p:spPr>
+          <a:xfrm>
+            <a:off x="4901184" y="5650992"/>
+            <a:ext cx="2514600" cy="256032"/>
+          </a:xfrm>
+          <a:prstGeom prst="rect">
+            <a:avLst/>
+          </a:prstGeom>
+          <a:noFill/>
+          <a:ln/>
+        </p:spPr>
+        <p:txBody>
+          <a:bodyPr wrap="square" lIns="0" tIns="0" rIns="0" bIns="0" rtlCol="0" anchor="ctr">
+            <a:normAutofit/>
+          </a:bodyPr>
+          <a:lstStyle/>
+          <a:p>
+            <a:pPr marL="0" indent="0" algn="l">
+              <a:buNone/>
+            </a:pPr>
+            <a:r>
+              <a:rPr lang="en-US" sz="1020" b="1" dirty="0">
+                <a:solidFill>
+                  <a:srgbClr val="544B46"/>
+                </a:solidFill>
+                <a:latin typeface="MiSans" pitchFamily="34" charset="0"/>
+                <a:ea typeface="MiSans" pitchFamily="34" charset="-122"/>
+                <a:cs typeface="MiSans" pitchFamily="34" charset="-120"/>
+              </a:rPr>
+              <a:t>4 个智能体 · 13 项工具 · 14 组协作绑定</a:t>
+            </a:r>
+            <a:endParaRPr lang="en-US" sz="1020" dirty="0"/>
+          </a:p>
+        </p:txBody>
+      </p:sp>
+      <p:sp>
+        <p:nvSpPr>
+          <p:cNvPr id="36" name="A08_0111_label-bg"/>
+          <p:cNvSpPr/>
+          <p:nvPr/>
+        </p:nvSpPr>
+        <p:spPr>
+          <a:xfrm>
+            <a:off x="7735824" y="5632704"/>
             <a:ext cx="2798064" cy="283464"/>
           </a:xfrm>
           <a:prstGeom prst="rect">
@@ -13170,13 +14036,13 @@
       </p:sp>
       <p:sp>
         <p:nvSpPr>
-          <p:cNvPr id="36" name="A08_0111_text"/>
-          <p:cNvSpPr/>
-          <p:nvPr/>
-        </p:nvSpPr>
-        <p:spPr>
-          <a:xfrm>
-            <a:off x="7443216" y="5650992"/>
+          <p:cNvPr id="37" name="A08_0112_text"/>
+          <p:cNvSpPr/>
+          <p:nvPr/>
+        </p:nvSpPr>
+        <p:spPr>
+          <a:xfrm>
+            <a:off x="7808976" y="5650992"/>
             <a:ext cx="2651760" cy="237744"/>
           </a:xfrm>
           <a:prstGeom prst="rect">
@@ -14271,7 +15137,7 @@
                                 </p:cTn>
                               </p:par>
                               <p:par>
-                                <p:cTn id="97" presetID="10" presetClass="entr" presetSubtype="0" fill="hold" nodeType="withEffect">
+                                <p:cTn id="97" presetID="10" presetClass="entr" presetSubtype="0" fill="hold" grpId="0" nodeType="withEffect">
                                   <p:stCondLst>
                                     <p:cond delay="0"/>
                                   </p:stCondLst>
@@ -14306,7 +15172,7 @@
                                 </p:cTn>
                               </p:par>
                               <p:par>
-                                <p:cTn id="100" presetID="10" presetClass="entr" presetSubtype="0" fill="hold" grpId="0" nodeType="withEffect">
+                                <p:cTn id="100" presetID="10" presetClass="entr" presetSubtype="0" fill="hold" nodeType="withEffect">
                                   <p:stCondLst>
                                     <p:cond delay="0"/>
                                   </p:stCondLst>
@@ -14334,6 +15200,41 @@
                                         <p:cTn id="102" dur="380"/>
                                         <p:tgtEl>
                                           <p:spTgt spid="36"/>
+                                        </p:tgtEl>
+                                      </p:cBhvr>
+                                    </p:animEffect>
+                                  </p:childTnLst>
+                                </p:cTn>
+                              </p:par>
+                              <p:par>
+                                <p:cTn id="103" presetID="10" presetClass="entr" presetSubtype="0" fill="hold" grpId="0" nodeType="withEffect">
+                                  <p:stCondLst>
+                                    <p:cond delay="0"/>
+                                  </p:stCondLst>
+                                  <p:childTnLst>
+                                    <p:set>
+                                      <p:cBhvr>
+                                        <p:cTn id="104" dur="1" fill="hold">
+                                          <p:stCondLst>
+                                            <p:cond delay="0"/>
+                                          </p:stCondLst>
+                                        </p:cTn>
+                                        <p:tgtEl>
+                                          <p:spTgt spid="37"/>
+                                        </p:tgtEl>
+                                        <p:attrNameLst>
+                                          <p:attrName>style.visibility</p:attrName>
+                                        </p:attrNameLst>
+                                      </p:cBhvr>
+                                      <p:to>
+                                        <p:strVal val="visible"/>
+                                      </p:to>
+                                    </p:set>
+                                    <p:animEffect transition="in" filter="fade">
+                                      <p:cBhvr>
+                                        <p:cTn id="105" dur="380"/>
+                                        <p:tgtEl>
+                                          <p:spTgt spid="37"/>
                                         </p:tgtEl>
                                       </p:cBhvr>
                                     </p:animEffect>
@@ -14385,7 +15286,8 @@
       <p:bldP spid="31" grpId="0" animBg="1"/>
       <p:bldP spid="33" grpId="0" animBg="1"/>
       <p:bldP spid="34" grpId="0" animBg="1"/>
-      <p:bldP spid="36" grpId="0" animBg="1"/>
+      <p:bldP spid="35" grpId="0" animBg="1"/>
+      <p:bldP spid="37" grpId="0" animBg="1"/>
     </p:bldLst>
   </p:timing>
 </p:sld>
@@ -14418,7 +15320,7 @@
       </p:grpSpPr>
       <p:sp>
         <p:nvSpPr>
-          <p:cNvPr id="2" name="S00_0112_background-field"/>
+          <p:cNvPr id="2" name="S00_0113_background-field"/>
           <p:cNvSpPr/>
           <p:nvPr/>
         </p:nvSpPr>
@@ -14447,7 +15349,7 @@
       </p:sp>
       <p:sp>
         <p:nvSpPr>
-          <p:cNvPr id="3" name="S00_0113_background-arc"/>
+          <p:cNvPr id="3" name="S00_0114_background-arc"/>
           <p:cNvSpPr/>
           <p:nvPr/>
         </p:nvSpPr>
@@ -14476,7 +15378,7 @@
       </p:sp>
       <p:sp>
         <p:nvSpPr>
-          <p:cNvPr id="4" name="S00_0114_text"/>
+          <p:cNvPr id="4" name="S00_0115_text"/>
           <p:cNvSpPr/>
           <p:nvPr/>
         </p:nvSpPr>
@@ -14509,7 +15411,7 @@
                 <a:ea typeface="MiSans" pitchFamily="34" charset="-122"/>
                 <a:cs typeface="MiSans" pitchFamily="34" charset="-120"/>
               </a:rPr>
-              <a:t>学生场景｜真实功能演示</a:t>
+              <a:t>学生场景｜从查课到找空间</a:t>
             </a:r>
             <a:endParaRPr lang="en-US" sz="1000" dirty="0"/>
           </a:p>
@@ -14517,7 +15419,7 @@
       </p:sp>
       <p:sp>
         <p:nvSpPr>
-          <p:cNvPr id="5" name="S00_0115_text"/>
+          <p:cNvPr id="5" name="S00_0116_text"/>
           <p:cNvSpPr/>
           <p:nvPr/>
         </p:nvSpPr>
@@ -14550,7 +15452,7 @@
                 <a:ea typeface="Noto Serif SC" pitchFamily="34" charset="-122"/>
                 <a:cs typeface="Noto Serif SC" pitchFamily="34" charset="-120"/>
               </a:rPr>
-              <a:t>一句话查课，也能继续追问</a:t>
+              <a:t>一句话查课，也能接着问</a:t>
             </a:r>
             <a:endParaRPr lang="en-US" sz="2700" dirty="0"/>
           </a:p>
@@ -14558,7 +15460,7 @@
       </p:sp>
       <p:sp>
         <p:nvSpPr>
-          <p:cNvPr id="6" name="S00_0116_text"/>
+          <p:cNvPr id="6" name="S00_0117_text"/>
           <p:cNvSpPr/>
           <p:nvPr/>
         </p:nvSpPr>
@@ -14591,7 +15493,7 @@
                 <a:ea typeface="MiSans" pitchFamily="34" charset="-122"/>
                 <a:cs typeface="MiSans" pitchFamily="34" charset="-120"/>
               </a:rPr>
-              <a:t>以下能力来自真实系统，可在在线体验中现场验证；演示数据包含真实班级、课程与教室对象。</a:t>
+              <a:t>学生不用反复选择查询入口；系统记住对象和时间，把下一句话接下去。</a:t>
             </a:r>
             <a:endParaRPr lang="en-US" sz="1220" dirty="0"/>
           </a:p>
@@ -14599,7 +15501,7 @@
       </p:sp>
       <p:sp>
         <p:nvSpPr>
-          <p:cNvPr id="7" name="S00_0117_text"/>
+          <p:cNvPr id="7" name="S00_0118_text"/>
           <p:cNvSpPr/>
           <p:nvPr/>
         </p:nvSpPr>
@@ -14640,7 +15542,7 @@
       </p:sp>
       <p:sp>
         <p:nvSpPr>
-          <p:cNvPr id="8" name="S00_0118_text"/>
+          <p:cNvPr id="8" name="S00_0119_text"/>
           <p:cNvSpPr/>
           <p:nvPr/>
         </p:nvSpPr>
@@ -14681,14 +15583,14 @@
       </p:sp>
       <p:sp>
         <p:nvSpPr>
-          <p:cNvPr id="9" name="A01_0119_text"/>
-          <p:cNvSpPr/>
-          <p:nvPr/>
-        </p:nvSpPr>
-        <p:spPr>
-          <a:xfrm>
-            <a:off x="749808" y="1755648"/>
-            <a:ext cx="548640" cy="292608"/>
+          <p:cNvPr id="9" name="A01_0120_text"/>
+          <p:cNvSpPr/>
+          <p:nvPr/>
+        </p:nvSpPr>
+        <p:spPr>
+          <a:xfrm>
+            <a:off x="749808" y="1773936"/>
+            <a:ext cx="438912" cy="274320"/>
           </a:xfrm>
           <a:prstGeom prst="rect">
             <a:avLst/>
@@ -14706,7 +15608,7 @@
               <a:buNone/>
             </a:pPr>
             <a:r>
-              <a:rPr lang="en-US" sz="1050" b="1" dirty="0">
+              <a:rPr lang="en-US" sz="1000" b="1" dirty="0">
                 <a:solidFill>
                   <a:srgbClr val="E65442"/>
                 </a:solidFill>
@@ -14716,20 +15618,20 @@
               </a:rPr>
               <a:t>01</a:t>
             </a:r>
-            <a:endParaRPr lang="en-US" sz="1050" dirty="0"/>
+            <a:endParaRPr lang="en-US" sz="1000" dirty="0"/>
           </a:p>
         </p:txBody>
       </p:sp>
       <p:sp>
         <p:nvSpPr>
-          <p:cNvPr id="10" name="A01_0120_text"/>
-          <p:cNvSpPr/>
-          <p:nvPr/>
-        </p:nvSpPr>
-        <p:spPr>
-          <a:xfrm>
-            <a:off x="1389888" y="1719072"/>
-            <a:ext cx="1554480" cy="402336"/>
+          <p:cNvPr id="10" name="A01_0121_text"/>
+          <p:cNvSpPr/>
+          <p:nvPr/>
+        </p:nvSpPr>
+        <p:spPr>
+          <a:xfrm>
+            <a:off x="1298448" y="1755648"/>
+            <a:ext cx="3218688" cy="457200"/>
           </a:xfrm>
           <a:prstGeom prst="rect">
             <a:avLst/>
@@ -14747,30 +15649,30 @@
               <a:buNone/>
             </a:pPr>
             <a:r>
-              <a:rPr lang="en-US" sz="1900" b="1" dirty="0">
+              <a:rPr lang="en-US" sz="1750" b="1" dirty="0">
                 <a:solidFill>
-                  <a:srgbClr val="E65442"/>
+                  <a:srgbClr val="211E1C"/>
                 </a:solidFill>
                 <a:latin typeface="Noto Serif SC" pitchFamily="34" charset="0"/>
                 <a:ea typeface="Noto Serif SC" pitchFamily="34" charset="-122"/>
                 <a:cs typeface="Noto Serif SC" pitchFamily="34" charset="-120"/>
               </a:rPr>
-              <a:t>查课表</a:t>
+              <a:t>“查看 01 班第 1 周课表。”</a:t>
             </a:r>
-            <a:endParaRPr lang="en-US" sz="1900" dirty="0"/>
+            <a:endParaRPr lang="en-US" sz="1750" dirty="0"/>
           </a:p>
         </p:txBody>
       </p:sp>
       <p:sp>
         <p:nvSpPr>
-          <p:cNvPr id="11" name="A01_0121_text"/>
-          <p:cNvSpPr/>
-          <p:nvPr/>
-        </p:nvSpPr>
-        <p:spPr>
-          <a:xfrm>
-            <a:off x="768096" y="2194560"/>
-            <a:ext cx="3703320" cy="512064"/>
+          <p:cNvPr id="11" name="A01_0122_text"/>
+          <p:cNvSpPr/>
+          <p:nvPr/>
+        </p:nvSpPr>
+        <p:spPr>
+          <a:xfrm>
+            <a:off x="1298448" y="2276856"/>
+            <a:ext cx="2926080" cy="274320"/>
           </a:xfrm>
           <a:prstGeom prst="rect">
             <a:avLst/>
@@ -14779,7 +15681,7 @@
           <a:ln/>
         </p:spPr>
         <p:txBody>
-          <a:bodyPr wrap="square" lIns="0" tIns="0" rIns="0" bIns="0" rtlCol="0" anchor="t">
+          <a:bodyPr wrap="square" lIns="0" tIns="0" rIns="0" bIns="0" rtlCol="0" anchor="ctr">
             <a:normAutofit/>
           </a:bodyPr>
           <a:lstStyle/>
@@ -14788,53 +15690,55 @@
               <a:buNone/>
             </a:pPr>
             <a:r>
-              <a:rPr lang="en-US" sz="1180" dirty="0">
+              <a:rPr lang="en-US" sz="1120" b="1" dirty="0">
                 <a:solidFill>
-                  <a:srgbClr val="544B46"/>
+                  <a:srgbClr val="E65442"/>
                 </a:solidFill>
                 <a:latin typeface="MiSans" pitchFamily="34" charset="0"/>
                 <a:ea typeface="MiSans" pitchFamily="34" charset="-122"/>
                 <a:cs typeface="MiSans" pitchFamily="34" charset="-120"/>
               </a:rPr>
-              <a:t>班级 / 教师 / 课程 / 教室，一句话查询。例如：“查看2025级计算机类01班第1周课表。”</a:t>
+              <a:t>先查清课程安排</a:t>
             </a:r>
-            <a:endParaRPr lang="en-US" sz="1180" dirty="0"/>
+            <a:endParaRPr lang="en-US" sz="1120" dirty="0"/>
           </a:p>
         </p:txBody>
       </p:sp>
       <p:sp>
         <p:nvSpPr>
-          <p:cNvPr id="12" name="A01_0122_line"/>
-          <p:cNvSpPr/>
-          <p:nvPr/>
-        </p:nvSpPr>
-        <p:spPr>
-          <a:xfrm>
-            <a:off x="768096" y="2688336"/>
-            <a:ext cx="3566160" cy="0"/>
+          <p:cNvPr id="12" name="A01_0123_arrow"/>
+          <p:cNvSpPr/>
+          <p:nvPr/>
+        </p:nvSpPr>
+        <p:spPr>
+          <a:xfrm>
+            <a:off x="950976" y="2432304"/>
+            <a:ext cx="0" cy="457200"/>
           </a:xfrm>
           <a:prstGeom prst="line">
             <a:avLst/>
           </a:prstGeom>
           <a:noFill/>
-          <a:ln w="11430">
+          <a:ln w="15240">
             <a:solidFill>
               <a:srgbClr val="DDD2CA"/>
             </a:solidFill>
             <a:prstDash val="solid"/>
+            <a:headEnd type="none"/>
+            <a:tailEnd type="triangle"/>
           </a:ln>
         </p:spPr>
       </p:sp>
       <p:sp>
         <p:nvSpPr>
-          <p:cNvPr id="13" name="A02_0123_text"/>
-          <p:cNvSpPr/>
-          <p:nvPr/>
-        </p:nvSpPr>
-        <p:spPr>
-          <a:xfrm>
-            <a:off x="749808" y="2743200"/>
-            <a:ext cx="548640" cy="292608"/>
+          <p:cNvPr id="13" name="A02_0124_text"/>
+          <p:cNvSpPr/>
+          <p:nvPr/>
+        </p:nvSpPr>
+        <p:spPr>
+          <a:xfrm>
+            <a:off x="749808" y="2944368"/>
+            <a:ext cx="438912" cy="274320"/>
           </a:xfrm>
           <a:prstGeom prst="rect">
             <a:avLst/>
@@ -14852,7 +15756,7 @@
               <a:buNone/>
             </a:pPr>
             <a:r>
-              <a:rPr lang="en-US" sz="1050" b="1" dirty="0">
+              <a:rPr lang="en-US" sz="1000" b="1" dirty="0">
                 <a:solidFill>
                   <a:srgbClr val="B96B2E"/>
                 </a:solidFill>
@@ -14862,20 +15766,20 @@
               </a:rPr>
               <a:t>02</a:t>
             </a:r>
-            <a:endParaRPr lang="en-US" sz="1050" dirty="0"/>
+            <a:endParaRPr lang="en-US" sz="1000" dirty="0"/>
           </a:p>
         </p:txBody>
       </p:sp>
       <p:sp>
         <p:nvSpPr>
-          <p:cNvPr id="14" name="A02_0124_text"/>
-          <p:cNvSpPr/>
-          <p:nvPr/>
-        </p:nvSpPr>
-        <p:spPr>
-          <a:xfrm>
-            <a:off x="1389888" y="2706624"/>
-            <a:ext cx="1554480" cy="402336"/>
+          <p:cNvPr id="14" name="A02_0125_text"/>
+          <p:cNvSpPr/>
+          <p:nvPr/>
+        </p:nvSpPr>
+        <p:spPr>
+          <a:xfrm>
+            <a:off x="1298448" y="2926080"/>
+            <a:ext cx="3218688" cy="457200"/>
           </a:xfrm>
           <a:prstGeom prst="rect">
             <a:avLst/>
@@ -14893,30 +15797,30 @@
               <a:buNone/>
             </a:pPr>
             <a:r>
-              <a:rPr lang="en-US" sz="1900" b="1" dirty="0">
+              <a:rPr lang="en-US" sz="1750" b="1" dirty="0">
                 <a:solidFill>
-                  <a:srgbClr val="B96B2E"/>
+                  <a:srgbClr val="211E1C"/>
                 </a:solidFill>
                 <a:latin typeface="Noto Serif SC" pitchFamily="34" charset="0"/>
                 <a:ea typeface="Noto Serif SC" pitchFamily="34" charset="-122"/>
                 <a:cs typeface="Noto Serif SC" pitchFamily="34" charset="-120"/>
               </a:rPr>
-              <a:t>连续追问</a:t>
+              <a:t>“只看周三。”</a:t>
             </a:r>
-            <a:endParaRPr lang="en-US" sz="1900" dirty="0"/>
+            <a:endParaRPr lang="en-US" sz="1750" dirty="0"/>
           </a:p>
         </p:txBody>
       </p:sp>
       <p:sp>
         <p:nvSpPr>
-          <p:cNvPr id="15" name="A02_0125_text"/>
-          <p:cNvSpPr/>
-          <p:nvPr/>
-        </p:nvSpPr>
-        <p:spPr>
-          <a:xfrm>
-            <a:off x="768096" y="3182112"/>
-            <a:ext cx="3703320" cy="512064"/>
+          <p:cNvPr id="15" name="A02_0126_text"/>
+          <p:cNvSpPr/>
+          <p:nvPr/>
+        </p:nvSpPr>
+        <p:spPr>
+          <a:xfrm>
+            <a:off x="1298448" y="3447288"/>
+            <a:ext cx="2926080" cy="274320"/>
           </a:xfrm>
           <a:prstGeom prst="rect">
             <a:avLst/>
@@ -14925,7 +15829,7 @@
           <a:ln/>
         </p:spPr>
         <p:txBody>
-          <a:bodyPr wrap="square" lIns="0" tIns="0" rIns="0" bIns="0" rtlCol="0" anchor="t">
+          <a:bodyPr wrap="square" lIns="0" tIns="0" rIns="0" bIns="0" rtlCol="0" anchor="ctr">
             <a:normAutofit/>
           </a:bodyPr>
           <a:lstStyle/>
@@ -14934,53 +15838,55 @@
               <a:buNone/>
             </a:pPr>
             <a:r>
-              <a:rPr lang="en-US" sz="1180" dirty="0">
+              <a:rPr lang="en-US" sz="1120" b="1" dirty="0">
                 <a:solidFill>
-                  <a:srgbClr val="544B46"/>
+                  <a:srgbClr val="B96B2E"/>
                 </a:solidFill>
                 <a:latin typeface="MiSans" pitchFamily="34" charset="0"/>
                 <a:ea typeface="MiSans" pitchFamily="34" charset="-122"/>
                 <a:cs typeface="MiSans" pitchFamily="34" charset="-120"/>
               </a:rPr>
-              <a:t>“只看周三。”“那下午呢？”“这节课在哪？”——上下文不丢，对象不换。</a:t>
+              <a:t>沿用班级与周次</a:t>
             </a:r>
-            <a:endParaRPr lang="en-US" sz="1180" dirty="0"/>
+            <a:endParaRPr lang="en-US" sz="1120" dirty="0"/>
           </a:p>
         </p:txBody>
       </p:sp>
       <p:sp>
         <p:nvSpPr>
-          <p:cNvPr id="16" name="A02_0126_line"/>
-          <p:cNvSpPr/>
-          <p:nvPr/>
-        </p:nvSpPr>
-        <p:spPr>
-          <a:xfrm>
-            <a:off x="768096" y="3675888"/>
-            <a:ext cx="3566160" cy="0"/>
+          <p:cNvPr id="16" name="A02_0127_arrow"/>
+          <p:cNvSpPr/>
+          <p:nvPr/>
+        </p:nvSpPr>
+        <p:spPr>
+          <a:xfrm>
+            <a:off x="950976" y="3602736"/>
+            <a:ext cx="0" cy="457200"/>
           </a:xfrm>
           <a:prstGeom prst="line">
             <a:avLst/>
           </a:prstGeom>
           <a:noFill/>
-          <a:ln w="11430">
+          <a:ln w="15240">
             <a:solidFill>
               <a:srgbClr val="DDD2CA"/>
             </a:solidFill>
             <a:prstDash val="solid"/>
+            <a:headEnd type="none"/>
+            <a:tailEnd type="triangle"/>
           </a:ln>
         </p:spPr>
       </p:sp>
       <p:sp>
         <p:nvSpPr>
-          <p:cNvPr id="17" name="A03_0127_text"/>
-          <p:cNvSpPr/>
-          <p:nvPr/>
-        </p:nvSpPr>
-        <p:spPr>
-          <a:xfrm>
-            <a:off x="749808" y="3730752"/>
-            <a:ext cx="548640" cy="292608"/>
+          <p:cNvPr id="17" name="A03_0128_text"/>
+          <p:cNvSpPr/>
+          <p:nvPr/>
+        </p:nvSpPr>
+        <p:spPr>
+          <a:xfrm>
+            <a:off x="749808" y="4114800"/>
+            <a:ext cx="438912" cy="274320"/>
           </a:xfrm>
           <a:prstGeom prst="rect">
             <a:avLst/>
@@ -14998,7 +15904,7 @@
               <a:buNone/>
             </a:pPr>
             <a:r>
-              <a:rPr lang="en-US" sz="1050" b="1" dirty="0">
+              <a:rPr lang="en-US" sz="1000" b="1" dirty="0">
                 <a:solidFill>
                   <a:srgbClr val="237F69"/>
                 </a:solidFill>
@@ -15008,20 +15914,20 @@
               </a:rPr>
               <a:t>03</a:t>
             </a:r>
-            <a:endParaRPr lang="en-US" sz="1050" dirty="0"/>
+            <a:endParaRPr lang="en-US" sz="1000" dirty="0"/>
           </a:p>
         </p:txBody>
       </p:sp>
       <p:sp>
         <p:nvSpPr>
-          <p:cNvPr id="18" name="A03_0128_text"/>
-          <p:cNvSpPr/>
-          <p:nvPr/>
-        </p:nvSpPr>
-        <p:spPr>
-          <a:xfrm>
-            <a:off x="1389888" y="3694176"/>
-            <a:ext cx="1554480" cy="402336"/>
+          <p:cNvPr id="18" name="A03_0129_text"/>
+          <p:cNvSpPr/>
+          <p:nvPr/>
+        </p:nvSpPr>
+        <p:spPr>
+          <a:xfrm>
+            <a:off x="1298448" y="4096512"/>
+            <a:ext cx="3218688" cy="457200"/>
           </a:xfrm>
           <a:prstGeom prst="rect">
             <a:avLst/>
@@ -15039,30 +15945,94 @@
               <a:buNone/>
             </a:pPr>
             <a:r>
-              <a:rPr lang="en-US" sz="1900" b="1" dirty="0">
+              <a:rPr lang="en-US" sz="1750" b="1" dirty="0">
                 <a:solidFill>
-                  <a:srgbClr val="237F69"/>
+                  <a:srgbClr val="211E1C"/>
                 </a:solidFill>
                 <a:latin typeface="Noto Serif SC" pitchFamily="34" charset="0"/>
                 <a:ea typeface="Noto Serif SC" pitchFamily="34" charset="-122"/>
                 <a:cs typeface="Noto Serif SC" pitchFamily="34" charset="-120"/>
               </a:rPr>
-              <a:t>找空教室</a:t>
+              <a:t>“下午哪里有空教室？”</a:t>
             </a:r>
-            <a:endParaRPr lang="en-US" sz="1900" dirty="0"/>
+            <a:endParaRPr lang="en-US" sz="1750" dirty="0"/>
           </a:p>
         </p:txBody>
       </p:sp>
       <p:sp>
         <p:nvSpPr>
-          <p:cNvPr id="19" name="A03_0129_text"/>
-          <p:cNvSpPr/>
-          <p:nvPr/>
-        </p:nvSpPr>
-        <p:spPr>
-          <a:xfrm>
-            <a:off x="768096" y="4169664"/>
-            <a:ext cx="3703320" cy="512064"/>
+          <p:cNvPr id="19" name="A03_0130_text"/>
+          <p:cNvSpPr/>
+          <p:nvPr/>
+        </p:nvSpPr>
+        <p:spPr>
+          <a:xfrm>
+            <a:off x="1298448" y="4617720"/>
+            <a:ext cx="2926080" cy="274320"/>
+          </a:xfrm>
+          <a:prstGeom prst="rect">
+            <a:avLst/>
+          </a:prstGeom>
+          <a:noFill/>
+          <a:ln/>
+        </p:spPr>
+        <p:txBody>
+          <a:bodyPr wrap="square" lIns="0" tIns="0" rIns="0" bIns="0" rtlCol="0" anchor="ctr">
+            <a:normAutofit/>
+          </a:bodyPr>
+          <a:lstStyle/>
+          <a:p>
+            <a:pPr marL="0" indent="0" algn="l">
+              <a:buNone/>
+            </a:pPr>
+            <a:r>
+              <a:rPr lang="en-US" sz="1120" b="1" dirty="0">
+                <a:solidFill>
+                  <a:srgbClr val="237F69"/>
+                </a:solidFill>
+                <a:latin typeface="MiSans" pitchFamily="34" charset="0"/>
+                <a:ea typeface="MiSans" pitchFamily="34" charset="-122"/>
+                <a:cs typeface="MiSans" pitchFamily="34" charset="-120"/>
+              </a:rPr>
+              <a:t>继续查询可用空间</a:t>
+            </a:r>
+            <a:endParaRPr lang="en-US" sz="1120" dirty="0"/>
+          </a:p>
+        </p:txBody>
+      </p:sp>
+      <p:sp>
+        <p:nvSpPr>
+          <p:cNvPr id="20" name="A04_0131_line"/>
+          <p:cNvSpPr/>
+          <p:nvPr/>
+        </p:nvSpPr>
+        <p:spPr>
+          <a:xfrm>
+            <a:off x="749808" y="5358384"/>
+            <a:ext cx="3639312" cy="0"/>
+          </a:xfrm>
+          <a:prstGeom prst="line">
+            <a:avLst/>
+          </a:prstGeom>
+          <a:noFill/>
+          <a:ln w="12700">
+            <a:solidFill>
+              <a:srgbClr val="DDD2CA"/>
+            </a:solidFill>
+            <a:prstDash val="solid"/>
+          </a:ln>
+        </p:spPr>
+      </p:sp>
+      <p:sp>
+        <p:nvSpPr>
+          <p:cNvPr id="21" name="A04_0132_text"/>
+          <p:cNvSpPr/>
+          <p:nvPr/>
+        </p:nvSpPr>
+        <p:spPr>
+          <a:xfrm>
+            <a:off x="749808" y="5532120"/>
+            <a:ext cx="3675888" cy="658368"/>
           </a:xfrm>
           <a:prstGeom prst="rect">
             <a:avLst/>
@@ -15080,169 +16050,40 @@
               <a:buNone/>
             </a:pPr>
             <a:r>
-              <a:rPr lang="en-US" sz="1180" dirty="0">
+              <a:rPr lang="en-US" sz="1340" b="1" dirty="0">
                 <a:solidFill>
-                  <a:srgbClr val="544B46"/>
-                </a:solidFill>
-                <a:latin typeface="MiSans" pitchFamily="34" charset="0"/>
-                <a:ea typeface="MiSans" pitchFamily="34" charset="-122"/>
-                <a:cs typeface="MiSans" pitchFamily="34" charset="-120"/>
-              </a:rPr>
-              <a:t>“周三下午哪里有空教室？”时间与空间一起回答，还可以继续筛。</a:t>
-            </a:r>
-            <a:endParaRPr lang="en-US" sz="1180" dirty="0"/>
-          </a:p>
-        </p:txBody>
-      </p:sp>
-      <p:sp>
-        <p:nvSpPr>
-          <p:cNvPr id="20" name="A03_0130_line"/>
-          <p:cNvSpPr/>
-          <p:nvPr/>
-        </p:nvSpPr>
-        <p:spPr>
-          <a:xfrm>
-            <a:off x="768096" y="4663440"/>
-            <a:ext cx="3566160" cy="0"/>
-          </a:xfrm>
-          <a:prstGeom prst="line">
-            <a:avLst/>
-          </a:prstGeom>
-          <a:noFill/>
-          <a:ln w="11430">
-            <a:solidFill>
-              <a:srgbClr val="DDD2CA"/>
-            </a:solidFill>
-            <a:prstDash val="solid"/>
-          </a:ln>
-        </p:spPr>
-      </p:sp>
-      <p:sp>
-        <p:nvSpPr>
-          <p:cNvPr id="21" name="A04_0131_text"/>
-          <p:cNvSpPr/>
-          <p:nvPr/>
-        </p:nvSpPr>
-        <p:spPr>
-          <a:xfrm>
-            <a:off x="749808" y="4718304"/>
-            <a:ext cx="548640" cy="292608"/>
-          </a:xfrm>
-          <a:prstGeom prst="rect">
-            <a:avLst/>
-          </a:prstGeom>
-          <a:noFill/>
-          <a:ln/>
-        </p:spPr>
-        <p:txBody>
-          <a:bodyPr wrap="square" lIns="0" tIns="0" rIns="0" bIns="0" rtlCol="0" anchor="ctr">
-            <a:normAutofit/>
-          </a:bodyPr>
-          <a:lstStyle/>
-          <a:p>
-            <a:pPr marL="0" indent="0" algn="l">
-              <a:buNone/>
-            </a:pPr>
-            <a:r>
-              <a:rPr lang="en-US" sz="1050" b="1" dirty="0">
-                <a:solidFill>
-                  <a:srgbClr val="507BA0"/>
-                </a:solidFill>
-                <a:latin typeface="MiSans" pitchFamily="34" charset="0"/>
-                <a:ea typeface="MiSans" pitchFamily="34" charset="-122"/>
-                <a:cs typeface="MiSans" pitchFamily="34" charset="-120"/>
-              </a:rPr>
-              <a:t>04</a:t>
-            </a:r>
-            <a:endParaRPr lang="en-US" sz="1050" dirty="0"/>
-          </a:p>
-        </p:txBody>
-      </p:sp>
-      <p:sp>
-        <p:nvSpPr>
-          <p:cNvPr id="22" name="A04_0132_text"/>
-          <p:cNvSpPr/>
-          <p:nvPr/>
-        </p:nvSpPr>
-        <p:spPr>
-          <a:xfrm>
-            <a:off x="1389888" y="4681728"/>
-            <a:ext cx="1554480" cy="402336"/>
-          </a:xfrm>
-          <a:prstGeom prst="rect">
-            <a:avLst/>
-          </a:prstGeom>
-          <a:noFill/>
-          <a:ln/>
-        </p:spPr>
-        <p:txBody>
-          <a:bodyPr wrap="square" lIns="0" tIns="0" rIns="0" bIns="0" rtlCol="0" anchor="ctr">
-            <a:normAutofit/>
-          </a:bodyPr>
-          <a:lstStyle/>
-          <a:p>
-            <a:pPr marL="0" indent="0" algn="l">
-              <a:buNone/>
-            </a:pPr>
-            <a:r>
-              <a:rPr lang="en-US" sz="1900" b="1" dirty="0">
-                <a:solidFill>
-                  <a:srgbClr val="507BA0"/>
+                  <a:srgbClr val="B83E32"/>
                 </a:solidFill>
                 <a:latin typeface="Noto Serif SC" pitchFamily="34" charset="0"/>
                 <a:ea typeface="Noto Serif SC" pitchFamily="34" charset="-122"/>
                 <a:cs typeface="Noto Serif SC" pitchFamily="34" charset="-120"/>
               </a:rPr>
-              <a:t>今日安排</a:t>
+              <a:t>不用重填班级，不用重选时间，</a:t>
             </a:r>
-            <a:endParaRPr lang="en-US" sz="1900" dirty="0"/>
-          </a:p>
-        </p:txBody>
-      </p:sp>
-      <p:sp>
-        <p:nvSpPr>
-          <p:cNvPr id="23" name="A04_0133_text"/>
-          <p:cNvSpPr/>
-          <p:nvPr/>
-        </p:nvSpPr>
-        <p:spPr>
-          <a:xfrm>
-            <a:off x="768096" y="5157216"/>
-            <a:ext cx="3703320" cy="512064"/>
-          </a:xfrm>
-          <a:prstGeom prst="rect">
-            <a:avLst/>
-          </a:prstGeom>
-          <a:noFill/>
-          <a:ln/>
-        </p:spPr>
-        <p:txBody>
-          <a:bodyPr wrap="square" lIns="0" tIns="0" rIns="0" bIns="0" rtlCol="0" anchor="t">
-            <a:normAutofit/>
-          </a:bodyPr>
-          <a:lstStyle/>
+            <a:endParaRPr lang="en-US" sz="1340" dirty="0"/>
+          </a:p>
           <a:p>
             <a:pPr marL="0" indent="0" algn="l">
               <a:buNone/>
             </a:pPr>
             <a:r>
-              <a:rPr lang="en-US" sz="1180" dirty="0">
+              <a:rPr lang="en-US" sz="1340" b="1" dirty="0">
                 <a:solidFill>
-                  <a:srgbClr val="544B46"/>
+                  <a:srgbClr val="B83E32"/>
                 </a:solidFill>
-                <a:latin typeface="MiSans" pitchFamily="34" charset="0"/>
-                <a:ea typeface="MiSans" pitchFamily="34" charset="-122"/>
-                <a:cs typeface="MiSans" pitchFamily="34" charset="-120"/>
+                <a:latin typeface="Noto Serif SC" pitchFamily="34" charset="0"/>
+                <a:ea typeface="Noto Serif SC" pitchFamily="34" charset="-122"/>
+                <a:cs typeface="Noto Serif SC" pitchFamily="34" charset="-120"/>
               </a:rPr>
-              <a:t>今天有什么课、几点在哪里，一次说清。</a:t>
+              <a:t>也不用学习教务系统的复杂入口。</a:t>
             </a:r>
-            <a:endParaRPr lang="en-US" sz="1180" dirty="0"/>
+            <a:endParaRPr lang="en-US" sz="1340" dirty="0"/>
           </a:p>
         </p:txBody>
       </p:sp>
       <p:sp>
         <p:nvSpPr>
-          <p:cNvPr id="24" name="A05_0134_screen-base"/>
+          <p:cNvPr id="22" name="A05_0133_screen-base"/>
           <p:cNvSpPr/>
           <p:nvPr/>
         </p:nvSpPr>
@@ -15267,7 +16108,7 @@
       </p:sp>
       <p:pic>
         <p:nvPicPr>
-          <p:cNvPr id="25" name="A05_0135_screen-image" descr="competition-project\assets\portal-capability-1920x1080-final.png"/>
+          <p:cNvPr id="23" name="A05_0134_screen-image" descr="competition-project\competition\final-delivery\assets\portal-capability-1920x1080-final.png"/>
           <p:cNvPicPr>
             <a:picLocks noChangeAspect="1"/>
           </p:cNvPicPr>
@@ -15291,14 +16132,14 @@
       </p:pic>
       <p:sp>
         <p:nvSpPr>
-          <p:cNvPr id="26" name="A05_0136_text"/>
-          <p:cNvSpPr/>
-          <p:nvPr/>
-        </p:nvSpPr>
-        <p:spPr>
-          <a:xfrm>
-            <a:off x="7863840" y="5888736"/>
-            <a:ext cx="3657600" cy="274320"/>
+          <p:cNvPr id="24" name="A05_0135_text"/>
+          <p:cNvSpPr/>
+          <p:nvPr/>
+        </p:nvSpPr>
+        <p:spPr>
+          <a:xfrm>
+            <a:off x="8028432" y="5888736"/>
+            <a:ext cx="3493008" cy="274320"/>
           </a:xfrm>
           <a:prstGeom prst="rect">
             <a:avLst/>
@@ -15324,50 +16165,9 @@
                 <a:ea typeface="MiSans" pitchFamily="34" charset="-122"/>
                 <a:cs typeface="MiSans" pitchFamily="34" charset="-120"/>
               </a:rPr>
-              <a:t>真实产品界面：学生查询是系统的第一入口</a:t>
+              <a:t>真实产品界面 · 学生能力可在线验证</a:t>
             </a:r>
             <a:endParaRPr lang="en-US" sz="1150" dirty="0"/>
-          </a:p>
-        </p:txBody>
-      </p:sp>
-      <p:sp>
-        <p:nvSpPr>
-          <p:cNvPr id="27" name="A06_0137_text"/>
-          <p:cNvSpPr/>
-          <p:nvPr/>
-        </p:nvSpPr>
-        <p:spPr>
-          <a:xfrm>
-            <a:off x="749808" y="5943600"/>
-            <a:ext cx="3931920" cy="512064"/>
-          </a:xfrm>
-          <a:prstGeom prst="rect">
-            <a:avLst/>
-          </a:prstGeom>
-          <a:noFill/>
-          <a:ln/>
-        </p:spPr>
-        <p:txBody>
-          <a:bodyPr wrap="square" lIns="0" tIns="0" rIns="0" bIns="0" rtlCol="0" anchor="t">
-            <a:normAutofit/>
-          </a:bodyPr>
-          <a:lstStyle/>
-          <a:p>
-            <a:pPr marL="0" indent="0" algn="l">
-              <a:buNone/>
-            </a:pPr>
-            <a:r>
-              <a:rPr lang="en-US" sz="1250" b="1" dirty="0">
-                <a:solidFill>
-                  <a:srgbClr val="B83E32"/>
-                </a:solidFill>
-                <a:latin typeface="Noto Serif SC" pitchFamily="34" charset="0"/>
-                <a:ea typeface="Noto Serif SC" pitchFamily="34" charset="-122"/>
-                <a:cs typeface="Noto Serif SC" pitchFamily="34" charset="-120"/>
-              </a:rPr>
-              <a:t>真实功能演示——没有包装的数字，只有可以直接上手的能力。</a:t>
-            </a:r>
-            <a:endParaRPr lang="en-US" sz="1250" dirty="0"/>
           </a:p>
         </p:txBody>
       </p:sp>
@@ -15817,15 +16617,33 @@
                                   </p:childTnLst>
                                 </p:cTn>
                               </p:par>
+                            </p:childTnLst>
+                          </p:cTn>
+                        </p:par>
+                      </p:childTnLst>
+                    </p:cTn>
+                  </p:par>
+                  <p:par>
+                    <p:cTn id="42" fill="hold">
+                      <p:stCondLst>
+                        <p:cond delay="indefinite"/>
+                      </p:stCondLst>
+                      <p:childTnLst>
+                        <p:par>
+                          <p:cTn id="43" fill="hold">
+                            <p:stCondLst>
+                              <p:cond delay="0"/>
+                            </p:stCondLst>
+                            <p:childTnLst>
                               <p:par>
-                                <p:cTn id="42" presetID="10" presetClass="entr" presetSubtype="0" fill="hold" nodeType="withEffect">
+                                <p:cTn id="44" presetID="10" presetClass="entr" presetSubtype="0" fill="hold" nodeType="clickEffect">
                                   <p:stCondLst>
                                     <p:cond delay="0"/>
                                   </p:stCondLst>
                                   <p:childTnLst>
                                     <p:set>
                                       <p:cBhvr>
-                                        <p:cTn id="43" dur="1" fill="hold">
+                                        <p:cTn id="45" dur="1" fill="hold">
                                           <p:stCondLst>
                                             <p:cond delay="0"/>
                                           </p:stCondLst>
@@ -15843,9 +16661,44 @@
                                     </p:set>
                                     <p:animEffect transition="in" filter="fade">
                                       <p:cBhvr>
-                                        <p:cTn id="44" dur="380"/>
+                                        <p:cTn id="46" dur="380"/>
                                         <p:tgtEl>
                                           <p:spTgt spid="20"/>
+                                        </p:tgtEl>
+                                      </p:cBhvr>
+                                    </p:animEffect>
+                                  </p:childTnLst>
+                                </p:cTn>
+                              </p:par>
+                              <p:par>
+                                <p:cTn id="47" presetID="10" presetClass="entr" presetSubtype="0" fill="hold" grpId="0" nodeType="withEffect">
+                                  <p:stCondLst>
+                                    <p:cond delay="0"/>
+                                  </p:stCondLst>
+                                  <p:childTnLst>
+                                    <p:set>
+                                      <p:cBhvr>
+                                        <p:cTn id="48" dur="1" fill="hold">
+                                          <p:stCondLst>
+                                            <p:cond delay="0"/>
+                                          </p:stCondLst>
+                                        </p:cTn>
+                                        <p:tgtEl>
+                                          <p:spTgt spid="21"/>
+                                        </p:tgtEl>
+                                        <p:attrNameLst>
+                                          <p:attrName>style.visibility</p:attrName>
+                                        </p:attrNameLst>
+                                      </p:cBhvr>
+                                      <p:to>
+                                        <p:strVal val="visible"/>
+                                      </p:to>
+                                    </p:set>
+                                    <p:animEffect transition="in" filter="fade">
+                                      <p:cBhvr>
+                                        <p:cTn id="49" dur="380"/>
+                                        <p:tgtEl>
+                                          <p:spTgt spid="21"/>
                                         </p:tgtEl>
                                       </p:cBhvr>
                                     </p:animEffect>
@@ -15859,32 +16712,32 @@
                     </p:cTn>
                   </p:par>
                   <p:par>
-                    <p:cTn id="45" fill="hold">
+                    <p:cTn id="50" fill="hold">
                       <p:stCondLst>
                         <p:cond delay="indefinite"/>
                       </p:stCondLst>
                       <p:childTnLst>
                         <p:par>
-                          <p:cTn id="46" fill="hold">
+                          <p:cTn id="51" fill="hold">
                             <p:stCondLst>
                               <p:cond delay="0"/>
                             </p:stCondLst>
                             <p:childTnLst>
                               <p:par>
-                                <p:cTn id="47" presetID="10" presetClass="entr" presetSubtype="0" fill="hold" grpId="0" nodeType="clickEffect">
+                                <p:cTn id="52" presetID="10" presetClass="entr" presetSubtype="0" fill="hold" nodeType="clickEffect">
                                   <p:stCondLst>
                                     <p:cond delay="0"/>
                                   </p:stCondLst>
                                   <p:childTnLst>
                                     <p:set>
                                       <p:cBhvr>
-                                        <p:cTn id="48" dur="1" fill="hold">
+                                        <p:cTn id="53" dur="1" fill="hold">
                                           <p:stCondLst>
                                             <p:cond delay="0"/>
                                           </p:stCondLst>
                                         </p:cTn>
                                         <p:tgtEl>
-                                          <p:spTgt spid="21"/>
+                                          <p:spTgt spid="22"/>
                                         </p:tgtEl>
                                         <p:attrNameLst>
                                           <p:attrName>style.visibility</p:attrName>
@@ -15896,9 +16749,9 @@
                                     </p:set>
                                     <p:animEffect transition="in" filter="fade">
                                       <p:cBhvr>
-                                        <p:cTn id="49" dur="380"/>
-                                        <p:tgtEl>
-                                          <p:spTgt spid="21"/>
+                                        <p:cTn id="54" dur="380"/>
+                                        <p:tgtEl>
+                                          <p:spTgt spid="22"/>
                                         </p:tgtEl>
                                       </p:cBhvr>
                                     </p:animEffect>
@@ -15906,20 +16759,20 @@
                                 </p:cTn>
                               </p:par>
                               <p:par>
-                                <p:cTn id="50" presetID="10" presetClass="entr" presetSubtype="0" fill="hold" grpId="0" nodeType="withEffect">
+                                <p:cTn id="55" presetID="10" presetClass="entr" presetSubtype="0" fill="hold" nodeType="withEffect">
                                   <p:stCondLst>
                                     <p:cond delay="0"/>
                                   </p:stCondLst>
                                   <p:childTnLst>
                                     <p:set>
                                       <p:cBhvr>
-                                        <p:cTn id="51" dur="1" fill="hold">
+                                        <p:cTn id="56" dur="1" fill="hold">
                                           <p:stCondLst>
                                             <p:cond delay="0"/>
                                           </p:stCondLst>
                                         </p:cTn>
                                         <p:tgtEl>
-                                          <p:spTgt spid="22"/>
+                                          <p:spTgt spid="23"/>
                                         </p:tgtEl>
                                         <p:attrNameLst>
                                           <p:attrName>style.visibility</p:attrName>
@@ -15931,9 +16784,9 @@
                                     </p:set>
                                     <p:animEffect transition="in" filter="fade">
                                       <p:cBhvr>
-                                        <p:cTn id="52" dur="380"/>
-                                        <p:tgtEl>
-                                          <p:spTgt spid="22"/>
+                                        <p:cTn id="57" dur="380"/>
+                                        <p:tgtEl>
+                                          <p:spTgt spid="23"/>
                                         </p:tgtEl>
                                       </p:cBhvr>
                                     </p:animEffect>
@@ -15941,20 +16794,20 @@
                                 </p:cTn>
                               </p:par>
                               <p:par>
-                                <p:cTn id="53" presetID="10" presetClass="entr" presetSubtype="0" fill="hold" grpId="0" nodeType="withEffect">
+                                <p:cTn id="58" presetID="10" presetClass="entr" presetSubtype="0" fill="hold" grpId="0" nodeType="withEffect">
                                   <p:stCondLst>
                                     <p:cond delay="0"/>
                                   </p:stCondLst>
                                   <p:childTnLst>
                                     <p:set>
                                       <p:cBhvr>
-                                        <p:cTn id="54" dur="1" fill="hold">
+                                        <p:cTn id="59" dur="1" fill="hold">
                                           <p:stCondLst>
                                             <p:cond delay="0"/>
                                           </p:stCondLst>
                                         </p:cTn>
                                         <p:tgtEl>
-                                          <p:spTgt spid="23"/>
+                                          <p:spTgt spid="24"/>
                                         </p:tgtEl>
                                         <p:attrNameLst>
                                           <p:attrName>style.visibility</p:attrName>
@@ -15966,185 +16819,9 @@
                                     </p:set>
                                     <p:animEffect transition="in" filter="fade">
                                       <p:cBhvr>
-                                        <p:cTn id="55" dur="380"/>
-                                        <p:tgtEl>
-                                          <p:spTgt spid="23"/>
-                                        </p:tgtEl>
-                                      </p:cBhvr>
-                                    </p:animEffect>
-                                  </p:childTnLst>
-                                </p:cTn>
-                              </p:par>
-                            </p:childTnLst>
-                          </p:cTn>
-                        </p:par>
-                      </p:childTnLst>
-                    </p:cTn>
-                  </p:par>
-                  <p:par>
-                    <p:cTn id="56" fill="hold">
-                      <p:stCondLst>
-                        <p:cond delay="indefinite"/>
-                      </p:stCondLst>
-                      <p:childTnLst>
-                        <p:par>
-                          <p:cTn id="57" fill="hold">
-                            <p:stCondLst>
-                              <p:cond delay="0"/>
-                            </p:stCondLst>
-                            <p:childTnLst>
-                              <p:par>
-                                <p:cTn id="58" presetID="10" presetClass="entr" presetSubtype="0" fill="hold" nodeType="clickEffect">
-                                  <p:stCondLst>
-                                    <p:cond delay="0"/>
-                                  </p:stCondLst>
-                                  <p:childTnLst>
-                                    <p:set>
-                                      <p:cBhvr>
-                                        <p:cTn id="59" dur="1" fill="hold">
-                                          <p:stCondLst>
-                                            <p:cond delay="0"/>
-                                          </p:stCondLst>
-                                        </p:cTn>
+                                        <p:cTn id="60" dur="380"/>
                                         <p:tgtEl>
                                           <p:spTgt spid="24"/>
-                                        </p:tgtEl>
-                                        <p:attrNameLst>
-                                          <p:attrName>style.visibility</p:attrName>
-                                        </p:attrNameLst>
-                                      </p:cBhvr>
-                                      <p:to>
-                                        <p:strVal val="visible"/>
-                                      </p:to>
-                                    </p:set>
-                                    <p:animEffect transition="in" filter="fade">
-                                      <p:cBhvr>
-                                        <p:cTn id="60" dur="380"/>
-                                        <p:tgtEl>
-                                          <p:spTgt spid="24"/>
-                                        </p:tgtEl>
-                                      </p:cBhvr>
-                                    </p:animEffect>
-                                  </p:childTnLst>
-                                </p:cTn>
-                              </p:par>
-                              <p:par>
-                                <p:cTn id="61" presetID="10" presetClass="entr" presetSubtype="0" fill="hold" nodeType="withEffect">
-                                  <p:stCondLst>
-                                    <p:cond delay="0"/>
-                                  </p:stCondLst>
-                                  <p:childTnLst>
-                                    <p:set>
-                                      <p:cBhvr>
-                                        <p:cTn id="62" dur="1" fill="hold">
-                                          <p:stCondLst>
-                                            <p:cond delay="0"/>
-                                          </p:stCondLst>
-                                        </p:cTn>
-                                        <p:tgtEl>
-                                          <p:spTgt spid="25"/>
-                                        </p:tgtEl>
-                                        <p:attrNameLst>
-                                          <p:attrName>style.visibility</p:attrName>
-                                        </p:attrNameLst>
-                                      </p:cBhvr>
-                                      <p:to>
-                                        <p:strVal val="visible"/>
-                                      </p:to>
-                                    </p:set>
-                                    <p:animEffect transition="in" filter="fade">
-                                      <p:cBhvr>
-                                        <p:cTn id="63" dur="380"/>
-                                        <p:tgtEl>
-                                          <p:spTgt spid="25"/>
-                                        </p:tgtEl>
-                                      </p:cBhvr>
-                                    </p:animEffect>
-                                  </p:childTnLst>
-                                </p:cTn>
-                              </p:par>
-                              <p:par>
-                                <p:cTn id="64" presetID="10" presetClass="entr" presetSubtype="0" fill="hold" grpId="0" nodeType="withEffect">
-                                  <p:stCondLst>
-                                    <p:cond delay="0"/>
-                                  </p:stCondLst>
-                                  <p:childTnLst>
-                                    <p:set>
-                                      <p:cBhvr>
-                                        <p:cTn id="65" dur="1" fill="hold">
-                                          <p:stCondLst>
-                                            <p:cond delay="0"/>
-                                          </p:stCondLst>
-                                        </p:cTn>
-                                        <p:tgtEl>
-                                          <p:spTgt spid="26"/>
-                                        </p:tgtEl>
-                                        <p:attrNameLst>
-                                          <p:attrName>style.visibility</p:attrName>
-                                        </p:attrNameLst>
-                                      </p:cBhvr>
-                                      <p:to>
-                                        <p:strVal val="visible"/>
-                                      </p:to>
-                                    </p:set>
-                                    <p:animEffect transition="in" filter="fade">
-                                      <p:cBhvr>
-                                        <p:cTn id="66" dur="380"/>
-                                        <p:tgtEl>
-                                          <p:spTgt spid="26"/>
-                                        </p:tgtEl>
-                                      </p:cBhvr>
-                                    </p:animEffect>
-                                  </p:childTnLst>
-                                </p:cTn>
-                              </p:par>
-                            </p:childTnLst>
-                          </p:cTn>
-                        </p:par>
-                      </p:childTnLst>
-                    </p:cTn>
-                  </p:par>
-                  <p:par>
-                    <p:cTn id="67" fill="hold">
-                      <p:stCondLst>
-                        <p:cond delay="indefinite"/>
-                      </p:stCondLst>
-                      <p:childTnLst>
-                        <p:par>
-                          <p:cTn id="68" fill="hold">
-                            <p:stCondLst>
-                              <p:cond delay="0"/>
-                            </p:stCondLst>
-                            <p:childTnLst>
-                              <p:par>
-                                <p:cTn id="69" presetID="10" presetClass="entr" presetSubtype="0" fill="hold" grpId="0" nodeType="clickEffect">
-                                  <p:stCondLst>
-                                    <p:cond delay="0"/>
-                                  </p:stCondLst>
-                                  <p:childTnLst>
-                                    <p:set>
-                                      <p:cBhvr>
-                                        <p:cTn id="70" dur="1" fill="hold">
-                                          <p:stCondLst>
-                                            <p:cond delay="0"/>
-                                          </p:stCondLst>
-                                        </p:cTn>
-                                        <p:tgtEl>
-                                          <p:spTgt spid="27"/>
-                                        </p:tgtEl>
-                                        <p:attrNameLst>
-                                          <p:attrName>style.visibility</p:attrName>
-                                        </p:attrNameLst>
-                                      </p:cBhvr>
-                                      <p:to>
-                                        <p:strVal val="visible"/>
-                                      </p:to>
-                                    </p:set>
-                                    <p:animEffect transition="in" filter="fade">
-                                      <p:cBhvr>
-                                        <p:cTn id="71" dur="380"/>
-                                        <p:tgtEl>
-                                          <p:spTgt spid="27"/>
                                         </p:tgtEl>
                                       </p:cBhvr>
                                     </p:animEffect>
@@ -16189,10 +16866,7 @@
       <p:bldP spid="18" grpId="0" animBg="1"/>
       <p:bldP spid="19" grpId="0" animBg="1"/>
       <p:bldP spid="21" grpId="0" animBg="1"/>
-      <p:bldP spid="22" grpId="0" animBg="1"/>
-      <p:bldP spid="23" grpId="0" animBg="1"/>
-      <p:bldP spid="26" grpId="0" animBg="1"/>
-      <p:bldP spid="27" grpId="0" animBg="1"/>
+      <p:bldP spid="24" grpId="0" animBg="1"/>
     </p:bldLst>
   </p:timing>
 </p:sld>
@@ -16225,7 +16899,7 @@
       </p:grpSpPr>
       <p:sp>
         <p:nvSpPr>
-          <p:cNvPr id="2" name="S00_0138_background-field"/>
+          <p:cNvPr id="2" name="S00_0136_background-field"/>
           <p:cNvSpPr/>
           <p:nvPr/>
         </p:nvSpPr>
@@ -16254,7 +16928,7 @@
       </p:sp>
       <p:sp>
         <p:nvSpPr>
-          <p:cNvPr id="3" name="S00_0139_background-arc"/>
+          <p:cNvPr id="3" name="S00_0137_background-arc"/>
           <p:cNvSpPr/>
           <p:nvPr/>
         </p:nvSpPr>
@@ -16283,7 +16957,7 @@
       </p:sp>
       <p:sp>
         <p:nvSpPr>
-          <p:cNvPr id="4" name="S00_0140_text"/>
+          <p:cNvPr id="4" name="S00_0138_text"/>
           <p:cNvSpPr/>
           <p:nvPr/>
         </p:nvSpPr>
@@ -16324,7 +16998,7 @@
       </p:sp>
       <p:sp>
         <p:nvSpPr>
-          <p:cNvPr id="5" name="S00_0141_text"/>
+          <p:cNvPr id="5" name="S00_0139_text"/>
           <p:cNvSpPr/>
           <p:nvPr/>
         </p:nvSpPr>
@@ -16365,7 +17039,7 @@
       </p:sp>
       <p:sp>
         <p:nvSpPr>
-          <p:cNvPr id="6" name="S00_0142_text"/>
+          <p:cNvPr id="6" name="S00_0140_text"/>
           <p:cNvSpPr/>
           <p:nvPr/>
         </p:nvSpPr>
@@ -16406,7 +17080,7 @@
       </p:sp>
       <p:sp>
         <p:nvSpPr>
-          <p:cNvPr id="7" name="S00_0143_text"/>
+          <p:cNvPr id="7" name="S00_0141_text"/>
           <p:cNvSpPr/>
           <p:nvPr/>
         </p:nvSpPr>
@@ -16447,7 +17121,7 @@
       </p:sp>
       <p:sp>
         <p:nvSpPr>
-          <p:cNvPr id="8" name="S00_0144_text"/>
+          <p:cNvPr id="8" name="S00_0142_text"/>
           <p:cNvSpPr/>
           <p:nvPr/>
         </p:nvSpPr>
@@ -16488,7 +17162,7 @@
       </p:sp>
       <p:sp>
         <p:nvSpPr>
-          <p:cNvPr id="9" name="A01_0145_text"/>
+          <p:cNvPr id="9" name="A01_0143_text"/>
           <p:cNvSpPr/>
           <p:nvPr/>
         </p:nvSpPr>
@@ -16529,7 +17203,7 @@
       </p:sp>
       <p:sp>
         <p:nvSpPr>
-          <p:cNvPr id="10" name="A01_0146_text"/>
+          <p:cNvPr id="10" name="A01_0144_text"/>
           <p:cNvSpPr/>
           <p:nvPr/>
         </p:nvSpPr>
@@ -16570,7 +17244,7 @@
       </p:sp>
       <p:sp>
         <p:nvSpPr>
-          <p:cNvPr id="11" name="A01_0147_arrow"/>
+          <p:cNvPr id="11" name="A01_0145_arrow"/>
           <p:cNvSpPr/>
           <p:nvPr/>
         </p:nvSpPr>
@@ -16595,7 +17269,7 @@
       </p:sp>
       <p:sp>
         <p:nvSpPr>
-          <p:cNvPr id="12" name="A02_0148_text"/>
+          <p:cNvPr id="12" name="A02_0146_text"/>
           <p:cNvSpPr/>
           <p:nvPr/>
         </p:nvSpPr>
@@ -16636,7 +17310,7 @@
       </p:sp>
       <p:sp>
         <p:nvSpPr>
-          <p:cNvPr id="13" name="A02_0149_text"/>
+          <p:cNvPr id="13" name="A02_0147_text"/>
           <p:cNvSpPr/>
           <p:nvPr/>
         </p:nvSpPr>
@@ -16677,7 +17351,7 @@
       </p:sp>
       <p:sp>
         <p:nvSpPr>
-          <p:cNvPr id="14" name="A02_0150_arrow"/>
+          <p:cNvPr id="14" name="A02_0148_arrow"/>
           <p:cNvSpPr/>
           <p:nvPr/>
         </p:nvSpPr>
@@ -16702,7 +17376,7 @@
       </p:sp>
       <p:sp>
         <p:nvSpPr>
-          <p:cNvPr id="15" name="A03_0151_text"/>
+          <p:cNvPr id="15" name="A03_0149_text"/>
           <p:cNvSpPr/>
           <p:nvPr/>
         </p:nvSpPr>
@@ -16743,7 +17417,7 @@
       </p:sp>
       <p:sp>
         <p:nvSpPr>
-          <p:cNvPr id="16" name="A03_0152_text"/>
+          <p:cNvPr id="16" name="A03_0150_text"/>
           <p:cNvSpPr/>
           <p:nvPr/>
         </p:nvSpPr>
@@ -16784,7 +17458,7 @@
       </p:sp>
       <p:sp>
         <p:nvSpPr>
-          <p:cNvPr id="17" name="A03_0153_arrow"/>
+          <p:cNvPr id="17" name="A03_0151_arrow"/>
           <p:cNvSpPr/>
           <p:nvPr/>
         </p:nvSpPr>
@@ -16809,7 +17483,7 @@
       </p:sp>
       <p:sp>
         <p:nvSpPr>
-          <p:cNvPr id="18" name="A04_0154_text"/>
+          <p:cNvPr id="18" name="A04_0152_text"/>
           <p:cNvSpPr/>
           <p:nvPr/>
         </p:nvSpPr>
@@ -16850,7 +17524,7 @@
       </p:sp>
       <p:sp>
         <p:nvSpPr>
-          <p:cNvPr id="19" name="A04_0155_text"/>
+          <p:cNvPr id="19" name="A04_0153_text"/>
           <p:cNvSpPr/>
           <p:nvPr/>
         </p:nvSpPr>
@@ -16891,7 +17565,7 @@
       </p:sp>
       <p:sp>
         <p:nvSpPr>
-          <p:cNvPr id="20" name="A05_0156_line"/>
+          <p:cNvPr id="20" name="A05_0154_line"/>
           <p:cNvSpPr/>
           <p:nvPr/>
         </p:nvSpPr>
@@ -16914,7 +17588,7 @@
       </p:sp>
       <p:sp>
         <p:nvSpPr>
-          <p:cNvPr id="21" name="A05_0157_screen-base"/>
+          <p:cNvPr id="21" name="A05_0155_screen-base"/>
           <p:cNvSpPr/>
           <p:nvPr/>
         </p:nvSpPr>
@@ -16939,7 +17613,7 @@
       </p:sp>
       <p:pic>
         <p:nvPicPr>
-          <p:cNvPr id="22" name="A05_0158_screen-image" descr="competition-project\qa\final-cut\4173-collaboration-1920x1080.png"/>
+          <p:cNvPr id="22" name="A05_0156_screen-image" descr="competition-project\competition\final-delivery\qa\final-cut\4173-collaboration-1920x1080.png"/>
           <p:cNvPicPr>
             <a:picLocks noChangeAspect="1"/>
           </p:cNvPicPr>
@@ -16963,7 +17637,7 @@
       </p:pic>
       <p:sp>
         <p:nvSpPr>
-          <p:cNvPr id="23" name="A06_0159_text"/>
+          <p:cNvPr id="23" name="A06_0157_text"/>
           <p:cNvSpPr/>
           <p:nvPr/>
         </p:nvSpPr>
@@ -17711,7 +18385,7 @@
       </p:grpSpPr>
       <p:sp>
         <p:nvSpPr>
-          <p:cNvPr id="2" name="S00_0160_background-field"/>
+          <p:cNvPr id="2" name="S00_0158_background-field"/>
           <p:cNvSpPr/>
           <p:nvPr/>
         </p:nvSpPr>
@@ -17740,7 +18414,7 @@
       </p:sp>
       <p:sp>
         <p:nvSpPr>
-          <p:cNvPr id="3" name="S00_0161_background-arc"/>
+          <p:cNvPr id="3" name="S00_0159_background-arc"/>
           <p:cNvSpPr/>
           <p:nvPr/>
         </p:nvSpPr>
@@ -17769,7 +18443,7 @@
       </p:sp>
       <p:sp>
         <p:nvSpPr>
-          <p:cNvPr id="4" name="S00_0162_text"/>
+          <p:cNvPr id="4" name="S00_0160_text"/>
           <p:cNvSpPr/>
           <p:nvPr/>
         </p:nvSpPr>
@@ -17810,7 +18484,7 @@
       </p:sp>
       <p:sp>
         <p:nvSpPr>
-          <p:cNvPr id="5" name="S00_0163_text"/>
+          <p:cNvPr id="5" name="S00_0161_text"/>
           <p:cNvSpPr/>
           <p:nvPr/>
         </p:nvSpPr>
@@ -17851,7 +18525,7 @@
       </p:sp>
       <p:sp>
         <p:nvSpPr>
-          <p:cNvPr id="6" name="S00_0164_text"/>
+          <p:cNvPr id="6" name="S00_0162_text"/>
           <p:cNvSpPr/>
           <p:nvPr/>
         </p:nvSpPr>
@@ -17892,7 +18566,7 @@
       </p:sp>
       <p:sp>
         <p:nvSpPr>
-          <p:cNvPr id="7" name="S00_0165_text"/>
+          <p:cNvPr id="7" name="S00_0163_text"/>
           <p:cNvSpPr/>
           <p:nvPr/>
         </p:nvSpPr>
@@ -17933,7 +18607,7 @@
       </p:sp>
       <p:sp>
         <p:nvSpPr>
-          <p:cNvPr id="8" name="S00_0166_text"/>
+          <p:cNvPr id="8" name="S00_0164_text"/>
           <p:cNvSpPr/>
           <p:nvPr/>
         </p:nvSpPr>
@@ -17974,7 +18648,7 @@
       </p:sp>
       <p:sp>
         <p:nvSpPr>
-          <p:cNvPr id="9" name="A01_0167_text"/>
+          <p:cNvPr id="9" name="A01_0165_text"/>
           <p:cNvSpPr/>
           <p:nvPr/>
         </p:nvSpPr>
@@ -18015,7 +18689,7 @@
       </p:sp>
       <p:sp>
         <p:nvSpPr>
-          <p:cNvPr id="10" name="A01_0168_text"/>
+          <p:cNvPr id="10" name="A01_0166_text"/>
           <p:cNvSpPr/>
           <p:nvPr/>
         </p:nvSpPr>
@@ -18056,7 +18730,7 @@
       </p:sp>
       <p:sp>
         <p:nvSpPr>
-          <p:cNvPr id="11" name="A01_0169_text"/>
+          <p:cNvPr id="11" name="A01_0167_text"/>
           <p:cNvSpPr/>
           <p:nvPr/>
         </p:nvSpPr>
@@ -18097,7 +18771,7 @@
       </p:sp>
       <p:sp>
         <p:nvSpPr>
-          <p:cNvPr id="12" name="A02_0170_text"/>
+          <p:cNvPr id="12" name="A02_0168_text"/>
           <p:cNvSpPr/>
           <p:nvPr/>
         </p:nvSpPr>
@@ -18138,7 +18812,7 @@
       </p:sp>
       <p:sp>
         <p:nvSpPr>
-          <p:cNvPr id="13" name="A02_0171_text"/>
+          <p:cNvPr id="13" name="A02_0169_text"/>
           <p:cNvSpPr/>
           <p:nvPr/>
         </p:nvSpPr>
@@ -18179,7 +18853,7 @@
       </p:sp>
       <p:sp>
         <p:nvSpPr>
-          <p:cNvPr id="14" name="A02_0172_text"/>
+          <p:cNvPr id="14" name="A02_0170_text"/>
           <p:cNvSpPr/>
           <p:nvPr/>
         </p:nvSpPr>
@@ -18220,7 +18894,7 @@
       </p:sp>
       <p:sp>
         <p:nvSpPr>
-          <p:cNvPr id="15" name="A03_0173_text"/>
+          <p:cNvPr id="15" name="A03_0171_text"/>
           <p:cNvSpPr/>
           <p:nvPr/>
         </p:nvSpPr>
@@ -18261,7 +18935,7 @@
       </p:sp>
       <p:sp>
         <p:nvSpPr>
-          <p:cNvPr id="16" name="A04_0174_reschedule-band"/>
+          <p:cNvPr id="16" name="A04_0172_reschedule-band"/>
           <p:cNvSpPr/>
           <p:nvPr/>
         </p:nvSpPr>
@@ -18290,7 +18964,7 @@
       </p:sp>
       <p:sp>
         <p:nvSpPr>
-          <p:cNvPr id="17" name="A04_0175_text"/>
+          <p:cNvPr id="17" name="A04_0173_text"/>
           <p:cNvSpPr/>
           <p:nvPr/>
         </p:nvSpPr>
@@ -18331,7 +19005,7 @@
       </p:sp>
       <p:sp>
         <p:nvSpPr>
-          <p:cNvPr id="18" name="A04_0176_text"/>
+          <p:cNvPr id="18" name="A04_0174_text"/>
           <p:cNvSpPr/>
           <p:nvPr/>
         </p:nvSpPr>
@@ -18372,7 +19046,7 @@
       </p:sp>
       <p:sp>
         <p:nvSpPr>
-          <p:cNvPr id="19" name="A04_0177_text"/>
+          <p:cNvPr id="19" name="A04_0175_text"/>
           <p:cNvSpPr/>
           <p:nvPr/>
         </p:nvSpPr>
@@ -18413,7 +19087,7 @@
       </p:sp>
       <p:sp>
         <p:nvSpPr>
-          <p:cNvPr id="20" name="A05_0178_screen-base"/>
+          <p:cNvPr id="20" name="A05_0176_screen-base"/>
           <p:cNvSpPr/>
           <p:nvPr/>
         </p:nvSpPr>
@@ -18438,7 +19112,7 @@
       </p:sp>
       <p:pic>
         <p:nvPicPr>
-          <p:cNvPr id="21" name="A05_0179_screen-image" descr="competition-project\qa\final-cut\4173-risk-1920x1080.png"/>
+          <p:cNvPr id="21" name="A05_0177_screen-image" descr="competition-project\competition\final-delivery\qa\final-cut\4173-risk-1920x1080.png"/>
           <p:cNvPicPr>
             <a:picLocks noChangeAspect="1"/>
           </p:cNvPicPr>
@@ -18462,7 +19136,7 @@
       </p:pic>
       <p:sp>
         <p:nvSpPr>
-          <p:cNvPr id="22" name="A06_0180_screen-base"/>
+          <p:cNvPr id="22" name="A06_0178_screen-base"/>
           <p:cNvSpPr/>
           <p:nvPr/>
         </p:nvSpPr>
@@ -18487,7 +19161,7 @@
       </p:sp>
       <p:pic>
         <p:nvPicPr>
-          <p:cNvPr id="23" name="A06_0181_screen-image" descr="competition-project\qa\final-cut\4173-reschedule-1920x1080.png"/>
+          <p:cNvPr id="23" name="A06_0179_screen-image" descr="competition-project\competition\final-delivery\qa\final-cut\4173-reschedule-1920x1080.png"/>
           <p:cNvPicPr>
             <a:picLocks noChangeAspect="1"/>
           </p:cNvPicPr>
@@ -19219,7 +19893,7 @@
       </p:grpSpPr>
       <p:sp>
         <p:nvSpPr>
-          <p:cNvPr id="2" name="S00_0182_background-field"/>
+          <p:cNvPr id="2" name="S00_0180_background-field"/>
           <p:cNvSpPr/>
           <p:nvPr/>
         </p:nvSpPr>
@@ -19248,7 +19922,7 @@
       </p:sp>
       <p:sp>
         <p:nvSpPr>
-          <p:cNvPr id="3" name="S00_0183_background-arc"/>
+          <p:cNvPr id="3" name="S00_0181_background-arc"/>
           <p:cNvSpPr/>
           <p:nvPr/>
         </p:nvSpPr>
@@ -19277,7 +19951,7 @@
       </p:sp>
       <p:sp>
         <p:nvSpPr>
-          <p:cNvPr id="4" name="S00_0184_text"/>
+          <p:cNvPr id="4" name="S00_0182_text"/>
           <p:cNvSpPr/>
           <p:nvPr/>
         </p:nvSpPr>
@@ -19318,7 +19992,7 @@
       </p:sp>
       <p:sp>
         <p:nvSpPr>
-          <p:cNvPr id="5" name="S00_0185_text"/>
+          <p:cNvPr id="5" name="S00_0183_text"/>
           <p:cNvSpPr/>
           <p:nvPr/>
         </p:nvSpPr>
@@ -19359,7 +20033,7 @@
       </p:sp>
       <p:sp>
         <p:nvSpPr>
-          <p:cNvPr id="6" name="S00_0186_text"/>
+          <p:cNvPr id="6" name="S00_0184_text"/>
           <p:cNvSpPr/>
           <p:nvPr/>
         </p:nvSpPr>
@@ -19400,7 +20074,7 @@
       </p:sp>
       <p:sp>
         <p:nvSpPr>
-          <p:cNvPr id="7" name="S00_0187_text"/>
+          <p:cNvPr id="7" name="S00_0185_text"/>
           <p:cNvSpPr/>
           <p:nvPr/>
         </p:nvSpPr>
@@ -19441,7 +20115,7 @@
       </p:sp>
       <p:sp>
         <p:nvSpPr>
-          <p:cNvPr id="8" name="S00_0188_text"/>
+          <p:cNvPr id="8" name="S00_0186_text"/>
           <p:cNvSpPr/>
           <p:nvPr/>
         </p:nvSpPr>
@@ -19482,7 +20156,7 @@
       </p:sp>
       <p:sp>
         <p:nvSpPr>
-          <p:cNvPr id="9" name="A01_0189_stage-dot"/>
+          <p:cNvPr id="9" name="A01_0187_stage-dot"/>
           <p:cNvSpPr/>
           <p:nvPr/>
         </p:nvSpPr>
@@ -19509,7 +20183,7 @@
       </p:sp>
       <p:sp>
         <p:nvSpPr>
-          <p:cNvPr id="10" name="A01_0190_text"/>
+          <p:cNvPr id="10" name="A01_0188_text"/>
           <p:cNvSpPr/>
           <p:nvPr/>
         </p:nvSpPr>
@@ -19550,7 +20224,7 @@
       </p:sp>
       <p:sp>
         <p:nvSpPr>
-          <p:cNvPr id="11" name="A01_0191_text"/>
+          <p:cNvPr id="11" name="A01_0189_text"/>
           <p:cNvSpPr/>
           <p:nvPr/>
         </p:nvSpPr>
@@ -19591,7 +20265,7 @@
       </p:sp>
       <p:sp>
         <p:nvSpPr>
-          <p:cNvPr id="12" name="A01_0192_text"/>
+          <p:cNvPr id="12" name="A01_0190_text"/>
           <p:cNvSpPr/>
           <p:nvPr/>
         </p:nvSpPr>
@@ -19632,7 +20306,7 @@
       </p:sp>
       <p:sp>
         <p:nvSpPr>
-          <p:cNvPr id="13" name="A01_0193_stage-line"/>
+          <p:cNvPr id="13" name="A01_0191_stage-line"/>
           <p:cNvSpPr/>
           <p:nvPr/>
         </p:nvSpPr>
@@ -19655,7 +20329,7 @@
       </p:sp>
       <p:sp>
         <p:nvSpPr>
-          <p:cNvPr id="14" name="A02_0194_stage-dot"/>
+          <p:cNvPr id="14" name="A02_0192_stage-dot"/>
           <p:cNvSpPr/>
           <p:nvPr/>
         </p:nvSpPr>
@@ -19682,7 +20356,7 @@
       </p:sp>
       <p:sp>
         <p:nvSpPr>
-          <p:cNvPr id="15" name="A02_0195_text"/>
+          <p:cNvPr id="15" name="A02_0193_text"/>
           <p:cNvSpPr/>
           <p:nvPr/>
         </p:nvSpPr>
@@ -19723,7 +20397,7 @@
       </p:sp>
       <p:sp>
         <p:nvSpPr>
-          <p:cNvPr id="16" name="A02_0196_text"/>
+          <p:cNvPr id="16" name="A02_0194_text"/>
           <p:cNvSpPr/>
           <p:nvPr/>
         </p:nvSpPr>
@@ -19764,7 +20438,7 @@
       </p:sp>
       <p:sp>
         <p:nvSpPr>
-          <p:cNvPr id="17" name="A02_0197_text"/>
+          <p:cNvPr id="17" name="A02_0195_text"/>
           <p:cNvSpPr/>
           <p:nvPr/>
         </p:nvSpPr>
@@ -19805,7 +20479,7 @@
       </p:sp>
       <p:sp>
         <p:nvSpPr>
-          <p:cNvPr id="18" name="A02_0198_stage-line"/>
+          <p:cNvPr id="18" name="A02_0196_stage-line"/>
           <p:cNvSpPr/>
           <p:nvPr/>
         </p:nvSpPr>
@@ -19828,7 +20502,7 @@
       </p:sp>
       <p:sp>
         <p:nvSpPr>
-          <p:cNvPr id="19" name="A03_0199_stage-dot"/>
+          <p:cNvPr id="19" name="A03_0197_stage-dot"/>
           <p:cNvSpPr/>
           <p:nvPr/>
         </p:nvSpPr>
@@ -19855,7 +20529,7 @@
       </p:sp>
       <p:sp>
         <p:nvSpPr>
-          <p:cNvPr id="20" name="A03_0200_text"/>
+          <p:cNvPr id="20" name="A03_0198_text"/>
           <p:cNvSpPr/>
           <p:nvPr/>
         </p:nvSpPr>
@@ -19896,7 +20570,7 @@
       </p:sp>
       <p:sp>
         <p:nvSpPr>
-          <p:cNvPr id="21" name="A03_0201_text"/>
+          <p:cNvPr id="21" name="A03_0199_text"/>
           <p:cNvSpPr/>
           <p:nvPr/>
         </p:nvSpPr>
@@ -19937,7 +20611,7 @@
       </p:sp>
       <p:sp>
         <p:nvSpPr>
-          <p:cNvPr id="22" name="A03_0202_text"/>
+          <p:cNvPr id="22" name="A03_0200_text"/>
           <p:cNvSpPr/>
           <p:nvPr/>
         </p:nvSpPr>
@@ -19978,7 +20652,7 @@
       </p:sp>
       <p:sp>
         <p:nvSpPr>
-          <p:cNvPr id="23" name="A04_0203_text"/>
+          <p:cNvPr id="23" name="A04_0201_text"/>
           <p:cNvSpPr/>
           <p:nvPr/>
         </p:nvSpPr>
@@ -20019,7 +20693,7 @@
       </p:sp>
       <p:sp>
         <p:nvSpPr>
-          <p:cNvPr id="24" name="A04_0204_screen-base"/>
+          <p:cNvPr id="24" name="A04_0202_screen-base"/>
           <p:cNvSpPr/>
           <p:nvPr/>
         </p:nvSpPr>
@@ -20044,7 +20718,7 @@
       </p:sp>
       <p:pic>
         <p:nvPicPr>
-          <p:cNvPr id="25" name="A04_0205_screen-image" descr="competition-project\qa\final-cut\4173-insight-1920x1080.png"/>
+          <p:cNvPr id="25" name="A04_0203_screen-image" descr="competition-project\competition\final-delivery\qa\final-cut\4173-insight-1920x1080.png"/>
           <p:cNvPicPr>
             <a:picLocks noChangeAspect="1"/>
           </p:cNvPicPr>
@@ -20810,7 +21484,7 @@
       </p:grpSpPr>
       <p:sp>
         <p:nvSpPr>
-          <p:cNvPr id="2" name="S00_0206_background-field"/>
+          <p:cNvPr id="2" name="S00_0204_background-field"/>
           <p:cNvSpPr/>
           <p:nvPr/>
         </p:nvSpPr>
@@ -20839,7 +21513,7 @@
       </p:sp>
       <p:sp>
         <p:nvSpPr>
-          <p:cNvPr id="3" name="S00_0207_background-arc"/>
+          <p:cNvPr id="3" name="S00_0205_background-arc"/>
           <p:cNvSpPr/>
           <p:nvPr/>
         </p:nvSpPr>
@@ -20868,7 +21542,7 @@
       </p:sp>
       <p:sp>
         <p:nvSpPr>
-          <p:cNvPr id="4" name="S00_0208_text"/>
+          <p:cNvPr id="4" name="S00_0206_text"/>
           <p:cNvSpPr/>
           <p:nvPr/>
         </p:nvSpPr>
@@ -20909,7 +21583,7 @@
       </p:sp>
       <p:sp>
         <p:nvSpPr>
-          <p:cNvPr id="5" name="S00_0209_text"/>
+          <p:cNvPr id="5" name="S00_0207_text"/>
           <p:cNvSpPr/>
           <p:nvPr/>
         </p:nvSpPr>
@@ -20950,7 +21624,7 @@
       </p:sp>
       <p:sp>
         <p:nvSpPr>
-          <p:cNvPr id="6" name="S00_0210_text"/>
+          <p:cNvPr id="6" name="S00_0208_text"/>
           <p:cNvSpPr/>
           <p:nvPr/>
         </p:nvSpPr>
@@ -20991,7 +21665,7 @@
       </p:sp>
       <p:sp>
         <p:nvSpPr>
-          <p:cNvPr id="7" name="S00_0211_text"/>
+          <p:cNvPr id="7" name="S00_0209_text"/>
           <p:cNvSpPr/>
           <p:nvPr/>
         </p:nvSpPr>
@@ -21032,7 +21706,7 @@
       </p:sp>
       <p:sp>
         <p:nvSpPr>
-          <p:cNvPr id="8" name="S00_0212_text"/>
+          <p:cNvPr id="8" name="S00_0210_text"/>
           <p:cNvSpPr/>
           <p:nvPr/>
         </p:nvSpPr>
@@ -21073,7 +21747,7 @@
       </p:sp>
       <p:sp>
         <p:nvSpPr>
-          <p:cNvPr id="9" name="A01_0213_main"/>
+          <p:cNvPr id="9" name="A01_0211_main"/>
           <p:cNvSpPr/>
           <p:nvPr/>
         </p:nvSpPr>
@@ -21100,7 +21774,7 @@
       </p:sp>
       <p:sp>
         <p:nvSpPr>
-          <p:cNvPr id="10" name="A01_0214_text"/>
+          <p:cNvPr id="10" name="A01_0212_text"/>
           <p:cNvSpPr/>
           <p:nvPr/>
         </p:nvSpPr>
@@ -21141,7 +21815,7 @@
       </p:sp>
       <p:sp>
         <p:nvSpPr>
-          <p:cNvPr id="11" name="A01_0215_text"/>
+          <p:cNvPr id="11" name="A01_0213_text"/>
           <p:cNvSpPr/>
           <p:nvPr/>
         </p:nvSpPr>
@@ -21182,7 +21856,7 @@
       </p:sp>
       <p:sp>
         <p:nvSpPr>
-          <p:cNvPr id="12" name="A02_0216_text"/>
+          <p:cNvPr id="12" name="A02_0214_text"/>
           <p:cNvSpPr/>
           <p:nvPr/>
         </p:nvSpPr>
@@ -21223,7 +21897,7 @@
       </p:sp>
       <p:sp>
         <p:nvSpPr>
-          <p:cNvPr id="13" name="A02_0217_line"/>
+          <p:cNvPr id="13" name="A02_0215_line"/>
           <p:cNvSpPr/>
           <p:nvPr/>
         </p:nvSpPr>
@@ -21246,7 +21920,7 @@
       </p:sp>
       <p:sp>
         <p:nvSpPr>
-          <p:cNvPr id="14" name="A02_0218_text"/>
+          <p:cNvPr id="14" name="A02_0216_text"/>
           <p:cNvSpPr/>
           <p:nvPr/>
         </p:nvSpPr>
@@ -21287,7 +21961,7 @@
       </p:sp>
       <p:sp>
         <p:nvSpPr>
-          <p:cNvPr id="15" name="A02_0219_double-arrow"/>
+          <p:cNvPr id="15" name="A02_0217_double-arrow"/>
           <p:cNvSpPr/>
           <p:nvPr/>
         </p:nvSpPr>
@@ -21312,7 +21986,7 @@
       </p:sp>
       <p:sp>
         <p:nvSpPr>
-          <p:cNvPr id="16" name="A03_0220_text"/>
+          <p:cNvPr id="16" name="A03_0218_text"/>
           <p:cNvSpPr/>
           <p:nvPr/>
         </p:nvSpPr>
@@ -21353,7 +22027,7 @@
       </p:sp>
       <p:sp>
         <p:nvSpPr>
-          <p:cNvPr id="17" name="A03_0221_line"/>
+          <p:cNvPr id="17" name="A03_0219_line"/>
           <p:cNvSpPr/>
           <p:nvPr/>
         </p:nvSpPr>
@@ -21376,7 +22050,7 @@
       </p:sp>
       <p:sp>
         <p:nvSpPr>
-          <p:cNvPr id="18" name="A03_0222_text"/>
+          <p:cNvPr id="18" name="A03_0220_text"/>
           <p:cNvSpPr/>
           <p:nvPr/>
         </p:nvSpPr>
@@ -21417,7 +22091,7 @@
       </p:sp>
       <p:sp>
         <p:nvSpPr>
-          <p:cNvPr id="19" name="A03_0223_double-arrow"/>
+          <p:cNvPr id="19" name="A03_0221_double-arrow"/>
           <p:cNvSpPr/>
           <p:nvPr/>
         </p:nvSpPr>
@@ -21442,7 +22116,7 @@
       </p:sp>
       <p:sp>
         <p:nvSpPr>
-          <p:cNvPr id="20" name="A04_0224_text"/>
+          <p:cNvPr id="20" name="A04_0222_text"/>
           <p:cNvSpPr/>
           <p:nvPr/>
         </p:nvSpPr>
@@ -21483,7 +22157,7 @@
       </p:sp>
       <p:sp>
         <p:nvSpPr>
-          <p:cNvPr id="21" name="A04_0225_line"/>
+          <p:cNvPr id="21" name="A04_0223_line"/>
           <p:cNvSpPr/>
           <p:nvPr/>
         </p:nvSpPr>
@@ -21506,7 +22180,7 @@
       </p:sp>
       <p:sp>
         <p:nvSpPr>
-          <p:cNvPr id="22" name="A04_0226_text"/>
+          <p:cNvPr id="22" name="A04_0224_text"/>
           <p:cNvSpPr/>
           <p:nvPr/>
         </p:nvSpPr>
@@ -21547,7 +22221,7 @@
       </p:sp>
       <p:sp>
         <p:nvSpPr>
-          <p:cNvPr id="23" name="A04_0227_double-arrow"/>
+          <p:cNvPr id="23" name="A04_0225_double-arrow"/>
           <p:cNvSpPr/>
           <p:nvPr/>
         </p:nvSpPr>
@@ -21572,7 +22246,7 @@
       </p:sp>
       <p:sp>
         <p:nvSpPr>
-          <p:cNvPr id="24" name="A05_0228_tools-band"/>
+          <p:cNvPr id="24" name="A05_0226_tools-band"/>
           <p:cNvSpPr/>
           <p:nvPr/>
         </p:nvSpPr>
@@ -21601,7 +22275,7 @@
       </p:sp>
       <p:sp>
         <p:nvSpPr>
-          <p:cNvPr id="25" name="A05_0229_text"/>
+          <p:cNvPr id="25" name="A05_0227_text"/>
           <p:cNvSpPr/>
           <p:nvPr/>
         </p:nvSpPr>
@@ -21642,7 +22316,7 @@
       </p:sp>
       <p:sp>
         <p:nvSpPr>
-          <p:cNvPr id="26" name="A05_0230_text"/>
+          <p:cNvPr id="26" name="A05_0228_text"/>
           <p:cNvSpPr/>
           <p:nvPr/>
         </p:nvSpPr>
@@ -21683,7 +22357,7 @@
       </p:sp>
       <p:sp>
         <p:nvSpPr>
-          <p:cNvPr id="27" name="A05_0231_line"/>
+          <p:cNvPr id="27" name="A05_0229_line"/>
           <p:cNvSpPr/>
           <p:nvPr/>
         </p:nvSpPr>
@@ -21706,7 +22380,7 @@
       </p:sp>
       <p:sp>
         <p:nvSpPr>
-          <p:cNvPr id="28" name="A05_0232_text"/>
+          <p:cNvPr id="28" name="A05_0230_text"/>
           <p:cNvSpPr/>
           <p:nvPr/>
         </p:nvSpPr>
@@ -21747,7 +22421,7 @@
       </p:sp>
       <p:sp>
         <p:nvSpPr>
-          <p:cNvPr id="29" name="A05_0233_text"/>
+          <p:cNvPr id="29" name="A05_0231_text"/>
           <p:cNvSpPr/>
           <p:nvPr/>
         </p:nvSpPr>
@@ -21788,7 +22462,7 @@
       </p:sp>
       <p:sp>
         <p:nvSpPr>
-          <p:cNvPr id="30" name="A05_0234_line"/>
+          <p:cNvPr id="30" name="A05_0232_line"/>
           <p:cNvSpPr/>
           <p:nvPr/>
         </p:nvSpPr>
@@ -21811,7 +22485,7 @@
       </p:sp>
       <p:sp>
         <p:nvSpPr>
-          <p:cNvPr id="31" name="A05_0235_text"/>
+          <p:cNvPr id="31" name="A05_0233_text"/>
           <p:cNvSpPr/>
           <p:nvPr/>
         </p:nvSpPr>
@@ -21852,7 +22526,7 @@
       </p:sp>
       <p:sp>
         <p:nvSpPr>
-          <p:cNvPr id="32" name="A05_0236_text"/>
+          <p:cNvPr id="32" name="A05_0234_text"/>
           <p:cNvSpPr/>
           <p:nvPr/>
         </p:nvSpPr>
@@ -21893,7 +22567,7 @@
       </p:sp>
       <p:sp>
         <p:nvSpPr>
-          <p:cNvPr id="33" name="A05_0237_line"/>
+          <p:cNvPr id="33" name="A05_0235_line"/>
           <p:cNvSpPr/>
           <p:nvPr/>
         </p:nvSpPr>
@@ -21916,7 +22590,7 @@
       </p:sp>
       <p:sp>
         <p:nvSpPr>
-          <p:cNvPr id="34" name="A05_0238_text"/>
+          <p:cNvPr id="34" name="A05_0236_text"/>
           <p:cNvSpPr/>
           <p:nvPr/>
         </p:nvSpPr>
@@ -21957,7 +22631,7 @@
       </p:sp>
       <p:sp>
         <p:nvSpPr>
-          <p:cNvPr id="35" name="A05_0239_text"/>
+          <p:cNvPr id="35" name="A05_0237_text"/>
           <p:cNvSpPr/>
           <p:nvPr/>
         </p:nvSpPr>
@@ -21998,7 +22672,7 @@
       </p:sp>
       <p:sp>
         <p:nvSpPr>
-          <p:cNvPr id="36" name="A05_0240_line"/>
+          <p:cNvPr id="36" name="A05_0238_line"/>
           <p:cNvSpPr/>
           <p:nvPr/>
         </p:nvSpPr>
@@ -22021,7 +22695,7 @@
       </p:sp>
       <p:sp>
         <p:nvSpPr>
-          <p:cNvPr id="37" name="A05_0241_text"/>
+          <p:cNvPr id="37" name="A05_0239_text"/>
           <p:cNvSpPr/>
           <p:nvPr/>
         </p:nvSpPr>
@@ -22062,7 +22736,7 @@
       </p:sp>
       <p:sp>
         <p:nvSpPr>
-          <p:cNvPr id="38" name="A05_0242_text"/>
+          <p:cNvPr id="38" name="A05_0240_text"/>
           <p:cNvSpPr/>
           <p:nvPr/>
         </p:nvSpPr>
@@ -22103,7 +22777,7 @@
       </p:sp>
       <p:sp>
         <p:nvSpPr>
-          <p:cNvPr id="39" name="A06_0243_text"/>
+          <p:cNvPr id="39" name="A06_0241_text"/>
           <p:cNvSpPr/>
           <p:nvPr/>
         </p:nvSpPr>
@@ -22144,7 +22818,7 @@
       </p:sp>
       <p:sp>
         <p:nvSpPr>
-          <p:cNvPr id="40" name="A06_0244_text"/>
+          <p:cNvPr id="40" name="A06_0242_text"/>
           <p:cNvSpPr/>
           <p:nvPr/>
         </p:nvSpPr>
@@ -22185,7 +22859,7 @@
       </p:sp>
       <p:sp>
         <p:nvSpPr>
-          <p:cNvPr id="41" name="A06_0245_text"/>
+          <p:cNvPr id="41" name="A06_0243_text"/>
           <p:cNvSpPr/>
           <p:nvPr/>
         </p:nvSpPr>
@@ -22226,7 +22900,7 @@
       </p:sp>
       <p:sp>
         <p:nvSpPr>
-          <p:cNvPr id="42" name="A06_0246_text"/>
+          <p:cNvPr id="42" name="A06_0244_text"/>
           <p:cNvSpPr/>
           <p:nvPr/>
         </p:nvSpPr>
@@ -22267,7 +22941,7 @@
       </p:sp>
       <p:sp>
         <p:nvSpPr>
-          <p:cNvPr id="43" name="A06_0247_text"/>
+          <p:cNvPr id="43" name="A06_0245_text"/>
           <p:cNvSpPr/>
           <p:nvPr/>
         </p:nvSpPr>
@@ -22308,7 +22982,7 @@
       </p:sp>
       <p:sp>
         <p:nvSpPr>
-          <p:cNvPr id="44" name="A06_0248_text"/>
+          <p:cNvPr id="44" name="A06_0246_text"/>
           <p:cNvSpPr/>
           <p:nvPr/>
         </p:nvSpPr>

</xml_diff>